<commit_message>
talk: add speaker notes (beyond_attention_paradigms.pptx)
</commit_message>
<xml_diff>
--- a/talk/beyond_attention_paradigms.pptx
+++ b/talk/beyond_attention_paradigms.pptx
@@ -113,6 +113,1136 @@
     </a:lvl9pPr>
   </p:defaultTextStyle>
 </p:presentation>
+</file>
+
+<file path=ppt/notesMasters/notesMaster1.xml><?xml version="1.0" encoding="utf-8"?>
+<p:notesMaster xmlns:a="http://schemas.openxmlformats.org/drawingml/2006/main" xmlns:p="http://schemas.openxmlformats.org/presentationml/2006/main" xmlns:r="http://schemas.openxmlformats.org/officeDocument/2006/relationships">
+  <p:cSld>
+    <p:bg>
+      <p:bgRef idx="1001">
+        <a:schemeClr val="bg1"/>
+      </p:bgRef>
+    </p:bg>
+    <p:spTree>
+      <p:nvGrpSpPr>
+        <p:cNvPr id="1" name=""/>
+        <p:cNvGrpSpPr/>
+        <p:nvPr/>
+      </p:nvGrpSpPr>
+      <p:grpSpPr>
+        <a:xfrm>
+          <a:off x="0" y="0"/>
+          <a:ext cx="0" cy="0"/>
+          <a:chOff x="0" y="0"/>
+          <a:chExt cx="0" cy="0"/>
+        </a:xfrm>
+      </p:grpSpPr>
+      <p:sp>
+        <p:nvSpPr>
+          <p:cNvPr id="2" name="Header Placeholder 1"/>
+          <p:cNvSpPr>
+            <a:spLocks noGrp="1"/>
+          </p:cNvSpPr>
+          <p:nvPr>
+            <p:ph type="hdr" sz="quarter"/>
+          </p:nvPr>
+        </p:nvSpPr>
+        <p:spPr>
+          <a:xfrm>
+            <a:off x="0" y="0"/>
+            <a:ext cx="2971800" cy="457200"/>
+          </a:xfrm>
+          <a:prstGeom prst="rect">
+            <a:avLst/>
+          </a:prstGeom>
+        </p:spPr>
+        <p:txBody>
+          <a:bodyPr vert="horz" lIns="91440" tIns="45720" rIns="91440" bIns="45720" rtlCol="0"/>
+          <a:lstStyle>
+            <a:lvl1pPr algn="l">
+              <a:defRPr sz="1200"/>
+            </a:lvl1pPr>
+          </a:lstStyle>
+          <a:p>
+            <a:endParaRPr lang="en-US"/>
+          </a:p>
+        </p:txBody>
+      </p:sp>
+      <p:sp>
+        <p:nvSpPr>
+          <p:cNvPr id="3" name="Date Placeholder 2"/>
+          <p:cNvSpPr>
+            <a:spLocks noGrp="1"/>
+          </p:cNvSpPr>
+          <p:nvPr>
+            <p:ph type="dt" idx="1"/>
+          </p:nvPr>
+        </p:nvSpPr>
+        <p:spPr>
+          <a:xfrm>
+            <a:off x="3884613" y="0"/>
+            <a:ext cx="2971800" cy="457200"/>
+          </a:xfrm>
+          <a:prstGeom prst="rect">
+            <a:avLst/>
+          </a:prstGeom>
+        </p:spPr>
+        <p:txBody>
+          <a:bodyPr vert="horz" lIns="91440" tIns="45720" rIns="91440" bIns="45720" rtlCol="0"/>
+          <a:lstStyle>
+            <a:lvl1pPr algn="r">
+              <a:defRPr sz="1200"/>
+            </a:lvl1pPr>
+          </a:lstStyle>
+          <a:p>
+            <a:fld id="{0F89C1C7-3DCD-1040-A9CF-14679D8B5DDD}" type="datetimeFigureOut">
+              <a:rPr lang="en-US" smtClean="0"/>
+              <a:t>10/17/16</a:t>
+            </a:fld>
+            <a:endParaRPr lang="en-US"/>
+          </a:p>
+        </p:txBody>
+      </p:sp>
+      <p:sp>
+        <p:nvSpPr>
+          <p:cNvPr id="4" name="Slide Image Placeholder 3"/>
+          <p:cNvSpPr>
+            <a:spLocks noGrp="1" noRot="1" noChangeAspect="1"/>
+          </p:cNvSpPr>
+          <p:nvPr>
+            <p:ph type="sldImg" idx="2"/>
+          </p:nvPr>
+        </p:nvSpPr>
+        <p:spPr>
+          <a:xfrm>
+            <a:off x="1143000" y="685800"/>
+            <a:ext cx="4572000" cy="3429000"/>
+          </a:xfrm>
+          <a:prstGeom prst="rect">
+            <a:avLst/>
+          </a:prstGeom>
+          <a:noFill/>
+          <a:ln w="12700">
+            <a:solidFill>
+              <a:prstClr val="black"/>
+            </a:solidFill>
+          </a:ln>
+        </p:spPr>
+        <p:txBody>
+          <a:bodyPr vert="horz" lIns="91440" tIns="45720" rIns="91440" bIns="45720" rtlCol="0" anchor="ctr"/>
+          <a:lstStyle/>
+          <a:p>
+            <a:endParaRPr lang="en-US"/>
+          </a:p>
+        </p:txBody>
+      </p:sp>
+      <p:sp>
+        <p:nvSpPr>
+          <p:cNvPr id="5" name="Notes Placeholder 4"/>
+          <p:cNvSpPr>
+            <a:spLocks noGrp="1"/>
+          </p:cNvSpPr>
+          <p:nvPr>
+            <p:ph type="body" sz="quarter" idx="3"/>
+          </p:nvPr>
+        </p:nvSpPr>
+        <p:spPr>
+          <a:xfrm>
+            <a:off x="685800" y="4343400"/>
+            <a:ext cx="5486400" cy="4114800"/>
+          </a:xfrm>
+          <a:prstGeom prst="rect">
+            <a:avLst/>
+          </a:prstGeom>
+        </p:spPr>
+        <p:txBody>
+          <a:bodyPr vert="horz" lIns="91440" tIns="45720" rIns="91440" bIns="45720" rtlCol="0"/>
+          <a:lstStyle/>
+          <a:p>
+            <a:pPr lvl="0"/>
+            <a:r>
+              <a:rPr lang="en-US" smtClean="0"/>
+              <a:t>Click to edit Master text styles</a:t>
+            </a:r>
+          </a:p>
+          <a:p>
+            <a:pPr lvl="1"/>
+            <a:r>
+              <a:rPr lang="en-US" smtClean="0"/>
+              <a:t>Second level</a:t>
+            </a:r>
+          </a:p>
+          <a:p>
+            <a:pPr lvl="2"/>
+            <a:r>
+              <a:rPr lang="en-US" smtClean="0"/>
+              <a:t>Third level</a:t>
+            </a:r>
+          </a:p>
+          <a:p>
+            <a:pPr lvl="3"/>
+            <a:r>
+              <a:rPr lang="en-US" smtClean="0"/>
+              <a:t>Fourth level</a:t>
+            </a:r>
+          </a:p>
+          <a:p>
+            <a:pPr lvl="4"/>
+            <a:r>
+              <a:rPr lang="en-US" smtClean="0"/>
+              <a:t>Fifth level</a:t>
+            </a:r>
+            <a:endParaRPr lang="en-US"/>
+          </a:p>
+        </p:txBody>
+      </p:sp>
+      <p:sp>
+        <p:nvSpPr>
+          <p:cNvPr id="6" name="Footer Placeholder 5"/>
+          <p:cNvSpPr>
+            <a:spLocks noGrp="1"/>
+          </p:cNvSpPr>
+          <p:nvPr>
+            <p:ph type="ftr" sz="quarter" idx="4"/>
+          </p:nvPr>
+        </p:nvSpPr>
+        <p:spPr>
+          <a:xfrm>
+            <a:off x="0" y="8685213"/>
+            <a:ext cx="2971800" cy="457200"/>
+          </a:xfrm>
+          <a:prstGeom prst="rect">
+            <a:avLst/>
+          </a:prstGeom>
+        </p:spPr>
+        <p:txBody>
+          <a:bodyPr vert="horz" lIns="91440" tIns="45720" rIns="91440" bIns="45720" rtlCol="0" anchor="b"/>
+          <a:lstStyle>
+            <a:lvl1pPr algn="l">
+              <a:defRPr sz="1200"/>
+            </a:lvl1pPr>
+          </a:lstStyle>
+          <a:p>
+            <a:endParaRPr lang="en-US"/>
+          </a:p>
+        </p:txBody>
+      </p:sp>
+      <p:sp>
+        <p:nvSpPr>
+          <p:cNvPr id="7" name="Slide Number Placeholder 6"/>
+          <p:cNvSpPr>
+            <a:spLocks noGrp="1"/>
+          </p:cNvSpPr>
+          <p:nvPr>
+            <p:ph type="sldNum" sz="quarter" idx="5"/>
+          </p:nvPr>
+        </p:nvSpPr>
+        <p:spPr>
+          <a:xfrm>
+            <a:off x="3884613" y="8685213"/>
+            <a:ext cx="2971800" cy="457200"/>
+          </a:xfrm>
+          <a:prstGeom prst="rect">
+            <a:avLst/>
+          </a:prstGeom>
+        </p:spPr>
+        <p:txBody>
+          <a:bodyPr vert="horz" lIns="91440" tIns="45720" rIns="91440" bIns="45720" rtlCol="0" anchor="b"/>
+          <a:lstStyle>
+            <a:lvl1pPr algn="r">
+              <a:defRPr sz="1200"/>
+            </a:lvl1pPr>
+          </a:lstStyle>
+          <a:p>
+            <a:fld id="{BB5E49A5-4136-284D-997B-48E1D791AD67}" type="slidenum">
+              <a:rPr lang="en-US" smtClean="0"/>
+              <a:t>‹#›</a:t>
+            </a:fld>
+            <a:endParaRPr lang="en-US"/>
+          </a:p>
+        </p:txBody>
+      </p:sp>
+    </p:spTree>
+    <p:extLst>
+      <p:ext uri="{BB962C8B-B14F-4D97-AF65-F5344CB8AC3E}">
+        <p14:creationId xmlns:p14="http://schemas.microsoft.com/office/powerpoint/2010/main" val="2623252185"/>
+      </p:ext>
+    </p:extLst>
+  </p:cSld>
+  <p:clrMap bg1="lt1" tx1="dk1" bg2="lt2" tx2="dk2" accent1="accent1" accent2="accent2" accent3="accent3" accent4="accent4" accent5="accent5" accent6="accent6" hlink="hlink" folHlink="folHlink"/>
+  <p:notesStyle>
+    <a:lvl1pPr marL="0" algn="l" defTabSz="457200" rtl="0" eaLnBrk="1" latinLnBrk="0" hangingPunct="1">
+      <a:defRPr sz="1200" kern="1200">
+        <a:solidFill>
+          <a:schemeClr val="tx1"/>
+        </a:solidFill>
+        <a:latin typeface="+mn-lt"/>
+        <a:ea typeface="+mn-ea"/>
+        <a:cs typeface="+mn-cs"/>
+      </a:defRPr>
+    </a:lvl1pPr>
+    <a:lvl2pPr marL="457200" algn="l" defTabSz="457200" rtl="0" eaLnBrk="1" latinLnBrk="0" hangingPunct="1">
+      <a:defRPr sz="1200" kern="1200">
+        <a:solidFill>
+          <a:schemeClr val="tx1"/>
+        </a:solidFill>
+        <a:latin typeface="+mn-lt"/>
+        <a:ea typeface="+mn-ea"/>
+        <a:cs typeface="+mn-cs"/>
+      </a:defRPr>
+    </a:lvl2pPr>
+    <a:lvl3pPr marL="914400" algn="l" defTabSz="457200" rtl="0" eaLnBrk="1" latinLnBrk="0" hangingPunct="1">
+      <a:defRPr sz="1200" kern="1200">
+        <a:solidFill>
+          <a:schemeClr val="tx1"/>
+        </a:solidFill>
+        <a:latin typeface="+mn-lt"/>
+        <a:ea typeface="+mn-ea"/>
+        <a:cs typeface="+mn-cs"/>
+      </a:defRPr>
+    </a:lvl3pPr>
+    <a:lvl4pPr marL="1371600" algn="l" defTabSz="457200" rtl="0" eaLnBrk="1" latinLnBrk="0" hangingPunct="1">
+      <a:defRPr sz="1200" kern="1200">
+        <a:solidFill>
+          <a:schemeClr val="tx1"/>
+        </a:solidFill>
+        <a:latin typeface="+mn-lt"/>
+        <a:ea typeface="+mn-ea"/>
+        <a:cs typeface="+mn-cs"/>
+      </a:defRPr>
+    </a:lvl4pPr>
+    <a:lvl5pPr marL="1828800" algn="l" defTabSz="457200" rtl="0" eaLnBrk="1" latinLnBrk="0" hangingPunct="1">
+      <a:defRPr sz="1200" kern="1200">
+        <a:solidFill>
+          <a:schemeClr val="tx1"/>
+        </a:solidFill>
+        <a:latin typeface="+mn-lt"/>
+        <a:ea typeface="+mn-ea"/>
+        <a:cs typeface="+mn-cs"/>
+      </a:defRPr>
+    </a:lvl5pPr>
+    <a:lvl6pPr marL="2286000" algn="l" defTabSz="457200" rtl="0" eaLnBrk="1" latinLnBrk="0" hangingPunct="1">
+      <a:defRPr sz="1200" kern="1200">
+        <a:solidFill>
+          <a:schemeClr val="tx1"/>
+        </a:solidFill>
+        <a:latin typeface="+mn-lt"/>
+        <a:ea typeface="+mn-ea"/>
+        <a:cs typeface="+mn-cs"/>
+      </a:defRPr>
+    </a:lvl6pPr>
+    <a:lvl7pPr marL="2743200" algn="l" defTabSz="457200" rtl="0" eaLnBrk="1" latinLnBrk="0" hangingPunct="1">
+      <a:defRPr sz="1200" kern="1200">
+        <a:solidFill>
+          <a:schemeClr val="tx1"/>
+        </a:solidFill>
+        <a:latin typeface="+mn-lt"/>
+        <a:ea typeface="+mn-ea"/>
+        <a:cs typeface="+mn-cs"/>
+      </a:defRPr>
+    </a:lvl7pPr>
+    <a:lvl8pPr marL="3200400" algn="l" defTabSz="457200" rtl="0" eaLnBrk="1" latinLnBrk="0" hangingPunct="1">
+      <a:defRPr sz="1200" kern="1200">
+        <a:solidFill>
+          <a:schemeClr val="tx1"/>
+        </a:solidFill>
+        <a:latin typeface="+mn-lt"/>
+        <a:ea typeface="+mn-ea"/>
+        <a:cs typeface="+mn-cs"/>
+      </a:defRPr>
+    </a:lvl8pPr>
+    <a:lvl9pPr marL="3657600" algn="l" defTabSz="457200" rtl="0" eaLnBrk="1" latinLnBrk="0" hangingPunct="1">
+      <a:defRPr sz="1200" kern="1200">
+        <a:solidFill>
+          <a:schemeClr val="tx1"/>
+        </a:solidFill>
+        <a:latin typeface="+mn-lt"/>
+        <a:ea typeface="+mn-ea"/>
+        <a:cs typeface="+mn-cs"/>
+      </a:defRPr>
+    </a:lvl9pPr>
+  </p:notesStyle>
+</p:notesMaster>
+</file>
+
+<file path=ppt/notesSlides/notesSlide1.xml><?xml version="1.0" encoding="utf-8"?>
+<p:notes xmlns:a="http://schemas.openxmlformats.org/drawingml/2006/main" xmlns:p="http://schemas.openxmlformats.org/presentationml/2006/main" xmlns:r="http://schemas.openxmlformats.org/officeDocument/2006/relationships">
+  <p:cSld>
+    <p:spTree>
+      <p:nvGrpSpPr>
+        <p:cNvPr id="1" name=""/>
+        <p:cNvGrpSpPr/>
+        <p:nvPr/>
+      </p:nvGrpSpPr>
+      <p:grpSpPr>
+        <a:xfrm>
+          <a:off x="0" y="0"/>
+          <a:ext cx="0" cy="0"/>
+          <a:chOff x="0" y="0"/>
+          <a:chExt cx="0" cy="0"/>
+        </a:xfrm>
+      </p:grpSpPr>
+      <p:sp>
+        <p:nvSpPr>
+          <p:cNvPr id="2" name="Slide Image Placeholder 1"/>
+          <p:cNvSpPr>
+            <a:spLocks noGrp="1"/>
+          </p:cNvSpPr>
+          <p:nvPr>
+            <p:ph type="sldImg" idx="2"/>
+          </p:nvPr>
+        </p:nvSpPr>
+        <p:spPr/>
+      </p:sp>
+      <p:sp>
+        <p:nvSpPr>
+          <p:cNvPr id="3" name="Notes Placeholder 2"/>
+          <p:cNvSpPr>
+            <a:spLocks noGrp="1"/>
+          </p:cNvSpPr>
+          <p:nvPr>
+            <p:ph type="body" idx="3" sz="quarter"/>
+          </p:nvPr>
+        </p:nvSpPr>
+        <p:spPr/>
+        <p:txBody>
+          <a:bodyPr/>
+          <a:lstStyle/>
+          <a:p>
+            <a:r>
+              <a:t>[~30s · open calm, set the frame]</a:t>
+            </a:r>
+          </a:p>
+          <a:p>
+            <a:r>
+              <a:t>Thanks for the time. I want to walk through a research direction that came out of a small empirical result of mine -- a short paper called "The Sparsity Ceiling."</a:t>
+            </a:r>
+          </a:p>
+          <a:p>
+            <a:r>
+              <a:t>One-line version: if spiking, brain-inspired hardware cannot ride the Transformer paradigm -- and I'll show you it structurally can't -- then the real question is what paradigm of intelligence it CAN ride. Today I map six candidates and say where I'd place the bet.</a:t>
+            </a:r>
+          </a:p>
+        </p:txBody>
+      </p:sp>
+      <p:sp>
+        <p:nvSpPr>
+          <p:cNvPr id="4" name="Slide Number Placeholder 3"/>
+          <p:cNvSpPr>
+            <a:spLocks noGrp="1"/>
+          </p:cNvSpPr>
+          <p:nvPr>
+            <p:ph type="sldNum" idx="5" sz="quarter"/>
+          </p:nvPr>
+        </p:nvSpPr>
+        <p:spPr/>
+      </p:sp>
+    </p:spTree>
+  </p:cSld>
+  <p:clrMapOvr>
+    <a:masterClrMapping/>
+  </p:clrMapOvr>
+</p:notes>
+</file>
+
+<file path=ppt/notesSlides/notesSlide2.xml><?xml version="1.0" encoding="utf-8"?>
+<p:notes xmlns:a="http://schemas.openxmlformats.org/drawingml/2006/main" xmlns:p="http://schemas.openxmlformats.org/presentationml/2006/main" xmlns:r="http://schemas.openxmlformats.org/officeDocument/2006/relationships">
+  <p:cSld>
+    <p:spTree>
+      <p:nvGrpSpPr>
+        <p:cNvPr id="1" name=""/>
+        <p:cNvGrpSpPr/>
+        <p:nvPr/>
+      </p:nvGrpSpPr>
+      <p:grpSpPr>
+        <a:xfrm>
+          <a:off x="0" y="0"/>
+          <a:ext cx="0" cy="0"/>
+          <a:chOff x="0" y="0"/>
+          <a:chExt cx="0" cy="0"/>
+        </a:xfrm>
+      </p:grpSpPr>
+      <p:sp>
+        <p:nvSpPr>
+          <p:cNvPr id="2" name="Slide Image Placeholder 1"/>
+          <p:cNvSpPr>
+            <a:spLocks noGrp="1"/>
+          </p:cNvSpPr>
+          <p:nvPr>
+            <p:ph type="sldImg" idx="2"/>
+          </p:nvPr>
+        </p:nvSpPr>
+        <p:spPr/>
+      </p:sp>
+      <p:sp>
+        <p:nvSpPr>
+          <p:cNvPr id="3" name="Notes Placeholder 2"/>
+          <p:cNvSpPr>
+            <a:spLocks noGrp="1"/>
+          </p:cNvSpPr>
+          <p:nvPr>
+            <p:ph type="body" idx="3" sz="quarter"/>
+          </p:nvPr>
+        </p:nvSpPr>
+        <p:spPr/>
+        <p:txBody>
+          <a:bodyPr/>
+          <a:lstStyle/>
+          <a:p>
+            <a:r>
+              <a:t>[~60s · this is the thesis slide -- slow down]</a:t>
+            </a:r>
+          </a:p>
+          <a:p>
+            <a:r>
+              <a:t>Start with what I think intelligence actually is. My working definition: a predictive generative model of the world, held in ongoing dynamics, that spends compute only on surprise and acts to test its own predictions. The key word is LOOP -- model interacting with world -- not a function that maps context to a token.</a:t>
+            </a:r>
+          </a:p>
+          <a:p>
+            <a:r>
+              <a:t>Transformers reach intelligence the opposite way: stateless, dense retrieval over the entire context, brute-forced with scale.</a:t>
+            </a:r>
+          </a:p>
+          <a:p>
+            <a:r>
+              <a:t>On the right is my empirical hook. In the sparsity-ceiling work, a recurrent spiking net hits a hard firing floor around 50% -- you cannot make it sparse. Attention CAN be made sparse, but only by storing the full key-value cache -- an O(context) memory wall. Either way, the Transformer route is mismatched to neuromorphic hardware. That mismatch is what motivates the whole talk.</a:t>
+            </a:r>
+          </a:p>
+        </p:txBody>
+      </p:sp>
+      <p:sp>
+        <p:nvSpPr>
+          <p:cNvPr id="4" name="Slide Number Placeholder 3"/>
+          <p:cNvSpPr>
+            <a:spLocks noGrp="1"/>
+          </p:cNvSpPr>
+          <p:nvPr>
+            <p:ph type="sldNum" idx="5" sz="quarter"/>
+          </p:nvPr>
+        </p:nvSpPr>
+        <p:spPr/>
+      </p:sp>
+    </p:spTree>
+  </p:cSld>
+  <p:clrMapOvr>
+    <a:masterClrMapping/>
+  </p:clrMapOvr>
+</p:notes>
+</file>
+
+<file path=ppt/notesSlides/notesSlide3.xml><?xml version="1.0" encoding="utf-8"?>
+<p:notes xmlns:a="http://schemas.openxmlformats.org/drawingml/2006/main" xmlns:p="http://schemas.openxmlformats.org/presentationml/2006/main" xmlns:r="http://schemas.openxmlformats.org/officeDocument/2006/relationships">
+  <p:cSld>
+    <p:spTree>
+      <p:nvGrpSpPr>
+        <p:cNvPr id="1" name=""/>
+        <p:cNvGrpSpPr/>
+        <p:nvPr/>
+      </p:nvGrpSpPr>
+      <p:grpSpPr>
+        <a:xfrm>
+          <a:off x="0" y="0"/>
+          <a:ext cx="0" cy="0"/>
+          <a:chOff x="0" y="0"/>
+          <a:chExt cx="0" cy="0"/>
+        </a:xfrm>
+      </p:grpSpPr>
+      <p:sp>
+        <p:nvSpPr>
+          <p:cNvPr id="2" name="Slide Image Placeholder 1"/>
+          <p:cNvSpPr>
+            <a:spLocks noGrp="1"/>
+          </p:cNvSpPr>
+          <p:nvPr>
+            <p:ph type="sldImg" idx="2"/>
+          </p:nvPr>
+        </p:nvSpPr>
+        <p:spPr/>
+      </p:sp>
+      <p:sp>
+        <p:nvSpPr>
+          <p:cNvPr id="3" name="Notes Placeholder 2"/>
+          <p:cNvSpPr>
+            <a:spLocks noGrp="1"/>
+          </p:cNvSpPr>
+          <p:nvPr>
+            <p:ph type="body" idx="3" sz="quarter"/>
+          </p:nvPr>
+        </p:nvSpPr>
+        <p:spPr/>
+        <p:txBody>
+          <a:bodyPr/>
+          <a:lstStyle/>
+          <a:p>
+            <a:r>
+              <a:t>[~45s · walk the last row hard]</a:t>
+            </a:r>
+          </a:p>
+          <a:p>
+            <a:r>
+              <a:t>Side by side, the two paradigms are almost point-for-point opposites. Transformer: stateless, external memory that grows with context, dense all-pairs compute, offline global backprop, intelligence from scale. Brain: persistent state, memory compressed into the state and synapses, compute spent only on prediction error, local online learning, intelligence from prediction and action.</a:t>
+            </a:r>
+          </a:p>
+          <a:p>
+            <a:r>
+              <a:t>The bottom row is the punchline for us: the Transformer column is exactly what neuromorphic hardware is bad at -- dense MACs and a memory wall -- and the brain column is exactly what it is good at -- event-driven, analog, local. So the paradigm choice and the hardware choice are the same choice.</a:t>
+            </a:r>
+          </a:p>
+        </p:txBody>
+      </p:sp>
+      <p:sp>
+        <p:nvSpPr>
+          <p:cNvPr id="4" name="Slide Number Placeholder 3"/>
+          <p:cNvSpPr>
+            <a:spLocks noGrp="1"/>
+          </p:cNvSpPr>
+          <p:nvPr>
+            <p:ph type="sldNum" idx="5" sz="quarter"/>
+          </p:nvPr>
+        </p:nvSpPr>
+        <p:spPr/>
+      </p:sp>
+    </p:spTree>
+  </p:cSld>
+  <p:clrMapOvr>
+    <a:masterClrMapping/>
+  </p:clrMapOvr>
+</p:notes>
+</file>
+
+<file path=ppt/notesSlides/notesSlide4.xml><?xml version="1.0" encoding="utf-8"?>
+<p:notes xmlns:a="http://schemas.openxmlformats.org/drawingml/2006/main" xmlns:p="http://schemas.openxmlformats.org/presentationml/2006/main" xmlns:r="http://schemas.openxmlformats.org/officeDocument/2006/relationships">
+  <p:cSld>
+    <p:spTree>
+      <p:nvGrpSpPr>
+        <p:cNvPr id="1" name=""/>
+        <p:cNvGrpSpPr/>
+        <p:nvPr/>
+      </p:nvGrpSpPr>
+      <p:grpSpPr>
+        <a:xfrm>
+          <a:off x="0" y="0"/>
+          <a:ext cx="0" cy="0"/>
+          <a:chOff x="0" y="0"/>
+          <a:chExt cx="0" cy="0"/>
+        </a:xfrm>
+      </p:grpSpPr>
+      <p:sp>
+        <p:nvSpPr>
+          <p:cNvPr id="2" name="Slide Image Placeholder 1"/>
+          <p:cNvSpPr>
+            <a:spLocks noGrp="1"/>
+          </p:cNvSpPr>
+          <p:nvPr>
+            <p:ph type="sldImg" idx="2"/>
+          </p:nvPr>
+        </p:nvSpPr>
+        <p:spPr/>
+      </p:sp>
+      <p:sp>
+        <p:nvSpPr>
+          <p:cNvPr id="3" name="Notes Placeholder 2"/>
+          <p:cNvSpPr>
+            <a:spLocks noGrp="1"/>
+          </p:cNvSpPr>
+          <p:nvPr>
+            <p:ph type="body" idx="3" sz="quarter"/>
+          </p:nvPr>
+        </p:nvSpPr>
+        <p:spPr/>
+        <p:txBody>
+          <a:bodyPr/>
+          <a:lstStyle/>
+          <a:p>
+            <a:r>
+              <a:t>[~55s · anticipate the obvious objection]</a:t>
+            </a:r>
+          </a:p>
+          <a:p>
+            <a:r>
+              <a:t>Here's the fair objection: my own paper proves recurrent spiking nets have a firing floor. So how does the brain -- which is recurrent and spiking -- avoid it?</a:t>
+            </a:r>
+          </a:p>
+          <a:p>
+            <a:r>
+              <a:t>Because the brain violates the assumption behind my bound. My bound assumes information travels ONLY in spikes. The brain doesn't. It holds memory in sub-threshold membrane potential and short-term synaptic state -- activity-silent -- and spikes only to signal errors. That escapes the firing floor AND the memory wall at once. Add an enormous neuron count, which pushes the required firing rate toward zero, and local multi-timescale learning.</a:t>
+            </a:r>
+          </a:p>
+          <a:p>
+            <a:r>
+              <a:t>The takeaway is the line at the bottom: the brain is an existence proof -- general intelligence at 20 watts, about a thousand times more efficient than GPUs -- using prediction and sparsity, not attention.</a:t>
+            </a:r>
+          </a:p>
+        </p:txBody>
+      </p:sp>
+      <p:sp>
+        <p:nvSpPr>
+          <p:cNvPr id="4" name="Slide Number Placeholder 3"/>
+          <p:cNvSpPr>
+            <a:spLocks noGrp="1"/>
+          </p:cNvSpPr>
+          <p:nvPr>
+            <p:ph type="sldNum" idx="5" sz="quarter"/>
+          </p:nvPr>
+        </p:nvSpPr>
+        <p:spPr/>
+      </p:sp>
+    </p:spTree>
+  </p:cSld>
+  <p:clrMapOvr>
+    <a:masterClrMapping/>
+  </p:clrMapOvr>
+</p:notes>
+</file>
+
+<file path=ppt/notesSlides/notesSlide5.xml><?xml version="1.0" encoding="utf-8"?>
+<p:notes xmlns:a="http://schemas.openxmlformats.org/drawingml/2006/main" xmlns:p="http://schemas.openxmlformats.org/presentationml/2006/main" xmlns:r="http://schemas.openxmlformats.org/officeDocument/2006/relationships">
+  <p:cSld>
+    <p:spTree>
+      <p:nvGrpSpPr>
+        <p:cNvPr id="1" name=""/>
+        <p:cNvGrpSpPr/>
+        <p:nvPr/>
+      </p:nvGrpSpPr>
+      <p:grpSpPr>
+        <a:xfrm>
+          <a:off x="0" y="0"/>
+          <a:ext cx="0" cy="0"/>
+          <a:chOff x="0" y="0"/>
+          <a:chExt cx="0" cy="0"/>
+        </a:xfrm>
+      </p:grpSpPr>
+      <p:sp>
+        <p:nvSpPr>
+          <p:cNvPr id="2" name="Slide Image Placeholder 1"/>
+          <p:cNvSpPr>
+            <a:spLocks noGrp="1"/>
+          </p:cNvSpPr>
+          <p:nvPr>
+            <p:ph type="sldImg" idx="2"/>
+          </p:nvPr>
+        </p:nvSpPr>
+        <p:spPr/>
+      </p:sp>
+      <p:sp>
+        <p:nvSpPr>
+          <p:cNvPr id="3" name="Notes Placeholder 2"/>
+          <p:cNvSpPr>
+            <a:spLocks noGrp="1"/>
+          </p:cNvSpPr>
+          <p:nvPr>
+            <p:ph type="body" idx="3" sz="quarter"/>
+          </p:nvPr>
+        </p:nvSpPr>
+        <p:spPr/>
+        <p:txBody>
+          <a:bodyPr/>
+          <a:lstStyle/>
+          <a:p>
+            <a:r>
+              <a:t>[~70s · this is the survey -- keep it brisk, one breath per row]</a:t>
+            </a:r>
+          </a:p>
+          <a:p>
+            <a:r>
+              <a:t>So if not attention, what? Six non-attention paradigms, each a real, active line of work.</a:t>
+            </a:r>
+          </a:p>
+          <a:p>
+            <a:r>
+              <a:t>Predictive coding -- hierarchical error propagation, local learning that provably approximates backprop.</a:t>
+            </a:r>
+          </a:p>
+          <a:p>
+            <a:r>
+              <a:t>Equilibrium propagation -- energy-based, local weight updates, analog-native, with hardware demos claiming four orders of magnitude less training energy.</a:t>
+            </a:r>
+          </a:p>
+          <a:p>
+            <a:r>
+              <a:t>Analog and spiking state-space models -- linear recurrence, no KV cache; keep the state in analog dynamics and you sidestep the firing floor.</a:t>
+            </a:r>
+          </a:p>
+          <a:p>
+            <a:r>
+              <a:t>World models and JEPA -- predict in latent space, plan by simulation.</a:t>
+            </a:r>
+          </a:p>
+          <a:p>
+            <a:r>
+              <a:t>Modern Hopfield / associative memory -- and this one is delightful: a Hopfield read is mathematically identical to attention, so the brain's "attention" is attractor dynamics, not QK-transpose.</a:t>
+            </a:r>
+          </a:p>
+          <a:p>
+            <a:r>
+              <a:t>Active inference -- minimize expected surprise in a perception-action loop.</a:t>
+            </a:r>
+          </a:p>
+          <a:p>
+            <a:r>
+              <a:t>The double checkmarks are where neuromorphic physics is an actual advantage, not just an algorithmic fit.</a:t>
+            </a:r>
+          </a:p>
+        </p:txBody>
+      </p:sp>
+      <p:sp>
+        <p:nvSpPr>
+          <p:cNvPr id="4" name="Slide Number Placeholder 3"/>
+          <p:cNvSpPr>
+            <a:spLocks noGrp="1"/>
+          </p:cNvSpPr>
+          <p:nvPr>
+            <p:ph type="sldNum" idx="5" sz="quarter"/>
+          </p:nvPr>
+        </p:nvSpPr>
+        <p:spPr/>
+      </p:sp>
+    </p:spTree>
+  </p:cSld>
+  <p:clrMapOvr>
+    <a:masterClrMapping/>
+  </p:clrMapOvr>
+</p:notes>
+</file>
+
+<file path=ppt/notesSlides/notesSlide6.xml><?xml version="1.0" encoding="utf-8"?>
+<p:notes xmlns:a="http://schemas.openxmlformats.org/drawingml/2006/main" xmlns:p="http://schemas.openxmlformats.org/presentationml/2006/main" xmlns:r="http://schemas.openxmlformats.org/officeDocument/2006/relationships">
+  <p:cSld>
+    <p:spTree>
+      <p:nvGrpSpPr>
+        <p:cNvPr id="1" name=""/>
+        <p:cNvGrpSpPr/>
+        <p:nvPr/>
+      </p:nvGrpSpPr>
+      <p:grpSpPr>
+        <a:xfrm>
+          <a:off x="0" y="0"/>
+          <a:ext cx="0" cy="0"/>
+          <a:chOff x="0" y="0"/>
+          <a:chExt cx="0" cy="0"/>
+        </a:xfrm>
+      </p:grpSpPr>
+      <p:sp>
+        <p:nvSpPr>
+          <p:cNvPr id="2" name="Slide Image Placeholder 1"/>
+          <p:cNvSpPr>
+            <a:spLocks noGrp="1"/>
+          </p:cNvSpPr>
+          <p:nvPr>
+            <p:ph type="sldImg" idx="2"/>
+          </p:nvPr>
+        </p:nvSpPr>
+        <p:spPr/>
+      </p:sp>
+      <p:sp>
+        <p:nvSpPr>
+          <p:cNvPr id="3" name="Notes Placeholder 2"/>
+          <p:cNvSpPr>
+            <a:spLocks noGrp="1"/>
+          </p:cNvSpPr>
+          <p:nvPr>
+            <p:ph type="body" idx="3" sz="quarter"/>
+          </p:nvPr>
+        </p:nvSpPr>
+        <p:spPr/>
+        <p:txBody>
+          <a:bodyPr/>
+          <a:lstStyle/>
+          <a:p>
+            <a:r>
+              <a:t>[~50s · commit -- say it like a conviction]</a:t>
+            </a:r>
+          </a:p>
+          <a:p>
+            <a:r>
+              <a:t>If I have to place the bet, it's this: a predictive world-model held in analog recurrent dynamics, learned locally and online -- predictive coding or equilibrium propagation -- acting in a closed loop, where spikes carry only surprise.</a:t>
+            </a:r>
+          </a:p>
+          <a:p>
+            <a:r>
+              <a:t>I want to stress this is not settling for less. It's choosing the paradigm where the hardware's physics is a feature, not a bug. Analog state escapes both the memory wall and the firing floor. Error-only propagation IS event-driven -- native to spiking silicon. Local plasticity means learning on-chip, no global backprop. And recurrence plus search gives you test-time reasoning without a giant single forward pass.</a:t>
+            </a:r>
+          </a:p>
+        </p:txBody>
+      </p:sp>
+      <p:sp>
+        <p:nvSpPr>
+          <p:cNvPr id="4" name="Slide Number Placeholder 3"/>
+          <p:cNvSpPr>
+            <a:spLocks noGrp="1"/>
+          </p:cNvSpPr>
+          <p:nvPr>
+            <p:ph type="sldNum" idx="5" sz="quarter"/>
+          </p:nvPr>
+        </p:nvSpPr>
+        <p:spPr/>
+      </p:sp>
+    </p:spTree>
+  </p:cSld>
+  <p:clrMapOvr>
+    <a:masterClrMapping/>
+  </p:clrMapOvr>
+</p:notes>
+</file>
+
+<file path=ppt/notesSlides/notesSlide7.xml><?xml version="1.0" encoding="utf-8"?>
+<p:notes xmlns:a="http://schemas.openxmlformats.org/drawingml/2006/main" xmlns:p="http://schemas.openxmlformats.org/presentationml/2006/main" xmlns:r="http://schemas.openxmlformats.org/officeDocument/2006/relationships">
+  <p:cSld>
+    <p:spTree>
+      <p:nvGrpSpPr>
+        <p:cNvPr id="1" name=""/>
+        <p:cNvGrpSpPr/>
+        <p:nvPr/>
+      </p:nvGrpSpPr>
+      <p:grpSpPr>
+        <a:xfrm>
+          <a:off x="0" y="0"/>
+          <a:ext cx="0" cy="0"/>
+          <a:chOff x="0" y="0"/>
+          <a:chExt cx="0" cy="0"/>
+        </a:xfrm>
+      </p:grpSpPr>
+      <p:sp>
+        <p:nvSpPr>
+          <p:cNvPr id="2" name="Slide Image Placeholder 1"/>
+          <p:cNvSpPr>
+            <a:spLocks noGrp="1"/>
+          </p:cNvSpPr>
+          <p:nvPr>
+            <p:ph type="sldImg" idx="2"/>
+          </p:nvPr>
+        </p:nvSpPr>
+        <p:spPr/>
+      </p:sp>
+      <p:sp>
+        <p:nvSpPr>
+          <p:cNvPr id="3" name="Notes Placeholder 2"/>
+          <p:cNvSpPr>
+            <a:spLocks noGrp="1"/>
+          </p:cNvSpPr>
+          <p:nvPr>
+            <p:ph type="body" idx="3" sz="quarter"/>
+          </p:nvPr>
+        </p:nvSpPr>
+        <p:spPr/>
+        <p:txBody>
+          <a:bodyPr/>
+          <a:lstStyle/>
+          <a:p>
+            <a:r>
+              <a:t>[~45s · say the hard part plainly -- this earns credibility]</a:t>
+            </a:r>
+          </a:p>
+          <a:p>
+            <a:r>
+              <a:t>Let me be honest about where this stands. None of these paradigms has beaten Transformers yet. Predictive coding, EqProp, SSMs, Hopfield, JEPA, active inference -- all promising, all more brain-like, none has produced GPT-class general capability. This is a research bet, not a finished alternative, and I'll state it as such.</a:t>
+            </a:r>
+          </a:p>
+          <a:p>
+            <a:r>
+              <a:t>But here's why it's still the right bet: the brain runs general intelligence on 20 watts using exactly this paradigm. So we know the paradigm CAN get there -- we just haven't reproduced it. That gap is the open frontier, and it is the reason to work on it, not the reason to avoid it.</a:t>
+            </a:r>
+          </a:p>
+        </p:txBody>
+      </p:sp>
+      <p:sp>
+        <p:nvSpPr>
+          <p:cNvPr id="4" name="Slide Number Placeholder 3"/>
+          <p:cNvSpPr>
+            <a:spLocks noGrp="1"/>
+          </p:cNvSpPr>
+          <p:nvPr>
+            <p:ph type="sldNum" idx="5" sz="quarter"/>
+          </p:nvPr>
+        </p:nvSpPr>
+        <p:spPr/>
+      </p:sp>
+    </p:spTree>
+  </p:cSld>
+  <p:clrMapOvr>
+    <a:masterClrMapping/>
+  </p:clrMapOvr>
+</p:notes>
+</file>
+
+<file path=ppt/notesSlides/notesSlide8.xml><?xml version="1.0" encoding="utf-8"?>
+<p:notes xmlns:a="http://schemas.openxmlformats.org/drawingml/2006/main" xmlns:p="http://schemas.openxmlformats.org/presentationml/2006/main" xmlns:r="http://schemas.openxmlformats.org/officeDocument/2006/relationships">
+  <p:cSld>
+    <p:spTree>
+      <p:nvGrpSpPr>
+        <p:cNvPr id="1" name=""/>
+        <p:cNvGrpSpPr/>
+        <p:nvPr/>
+      </p:nvGrpSpPr>
+      <p:grpSpPr>
+        <a:xfrm>
+          <a:off x="0" y="0"/>
+          <a:ext cx="0" cy="0"/>
+          <a:chOff x="0" y="0"/>
+          <a:chExt cx="0" cy="0"/>
+        </a:xfrm>
+      </p:grpSpPr>
+      <p:sp>
+        <p:nvSpPr>
+          <p:cNvPr id="2" name="Slide Image Placeholder 1"/>
+          <p:cNvSpPr>
+            <a:spLocks noGrp="1"/>
+          </p:cNvSpPr>
+          <p:nvPr>
+            <p:ph type="sldImg" idx="2"/>
+          </p:nvPr>
+        </p:nvSpPr>
+        <p:spPr/>
+      </p:sp>
+      <p:sp>
+        <p:nvSpPr>
+          <p:cNvPr id="3" name="Notes Placeholder 2"/>
+          <p:cNvSpPr>
+            <a:spLocks noGrp="1"/>
+          </p:cNvSpPr>
+          <p:nvPr>
+            <p:ph type="body" idx="3" sz="quarter"/>
+          </p:nvPr>
+        </p:nvSpPr>
+        <p:spPr/>
+        <p:txBody>
+          <a:bodyPr/>
+          <a:lstStyle/>
+          <a:p>
+            <a:r>
+              <a:t>[~55s · concrete -- this is what you'd actually do in the lab]</a:t>
+            </a:r>
+          </a:p>
+          <a:p>
+            <a:r>
+              <a:t>Concretely, four things I'd work on.</a:t>
+            </a:r>
+          </a:p>
+          <a:p>
+            <a:r>
+              <a:t>One: build a state-space model whose recurrent state lives in analog sub-threshold dynamics rather than spikes, and test directly whether it breaks my bound's assumption and sparsifies the way attention did.</a:t>
+            </a:r>
+          </a:p>
+          <a:p>
+            <a:r>
+              <a:t>Two: implement predictive coding on neuromorphic silicon with local equilibrium-propagation learning, and measure real energy on Loihi 2 or SpiNNaker2 -- turning my 45-nanometer proxy into an actual measurement.</a:t>
+            </a:r>
+          </a:p>
+          <a:p>
+            <a:r>
+              <a:t>Three: formalize the recurrence-versus-attention, firing-floor-versus-memory-wall trade-off as a conservation law, and find where analog-state models sit on that frontier.</a:t>
+            </a:r>
+          </a:p>
+          <a:p>
+            <a:r>
+              <a:t>Four: a closed-loop predictive world-model for a low-power embodied agent, where neuromorphic's real-time, event-driven physics is decisive.</a:t>
+            </a:r>
+          </a:p>
+          <a:p>
+            <a:r>
+              <a:t>Any of these is a first project; the first two I could start now.</a:t>
+            </a:r>
+          </a:p>
+        </p:txBody>
+      </p:sp>
+      <p:sp>
+        <p:nvSpPr>
+          <p:cNvPr id="4" name="Slide Number Placeholder 3"/>
+          <p:cNvSpPr>
+            <a:spLocks noGrp="1"/>
+          </p:cNvSpPr>
+          <p:nvPr>
+            <p:ph type="sldNum" idx="5" sz="quarter"/>
+          </p:nvPr>
+        </p:nvSpPr>
+        <p:spPr/>
+      </p:sp>
+    </p:spTree>
+  </p:cSld>
+  <p:clrMapOvr>
+    <a:masterClrMapping/>
+  </p:clrMapOvr>
+</p:notes>
+</file>
+
+<file path=ppt/notesSlides/notesSlide9.xml><?xml version="1.0" encoding="utf-8"?>
+<p:notes xmlns:a="http://schemas.openxmlformats.org/drawingml/2006/main" xmlns:p="http://schemas.openxmlformats.org/presentationml/2006/main" xmlns:r="http://schemas.openxmlformats.org/officeDocument/2006/relationships">
+  <p:cSld>
+    <p:spTree>
+      <p:nvGrpSpPr>
+        <p:cNvPr id="1" name=""/>
+        <p:cNvGrpSpPr/>
+        <p:nvPr/>
+      </p:nvGrpSpPr>
+      <p:grpSpPr>
+        <a:xfrm>
+          <a:off x="0" y="0"/>
+          <a:ext cx="0" cy="0"/>
+          <a:chOff x="0" y="0"/>
+          <a:chExt cx="0" cy="0"/>
+        </a:xfrm>
+      </p:grpSpPr>
+      <p:sp>
+        <p:nvSpPr>
+          <p:cNvPr id="2" name="Slide Image Placeholder 1"/>
+          <p:cNvSpPr>
+            <a:spLocks noGrp="1"/>
+          </p:cNvSpPr>
+          <p:nvPr>
+            <p:ph type="sldImg" idx="2"/>
+          </p:nvPr>
+        </p:nvSpPr>
+        <p:spPr/>
+      </p:sp>
+      <p:sp>
+        <p:nvSpPr>
+          <p:cNvPr id="3" name="Notes Placeholder 2"/>
+          <p:cNvSpPr>
+            <a:spLocks noGrp="1"/>
+          </p:cNvSpPr>
+          <p:nvPr>
+            <p:ph type="body" idx="3" sz="quarter"/>
+          </p:nvPr>
+        </p:nvSpPr>
+        <p:spPr/>
+        <p:txBody>
+          <a:bodyPr/>
+          <a:lstStyle/>
+          <a:p>
+            <a:r>
+              <a:t>[~25s · land it, then open for questions]</a:t>
+            </a:r>
+          </a:p>
+          <a:p>
+            <a:r>
+              <a:t>To close: intelligence is a loop, not a lookup. If neuromorphic hardware can't ride attention, it shouldn't try -- its physics aligns with the predictive, sparse, local, embodied paradigm that the brain already proves works at 20 watts. That's the direction I want to pursue.</a:t>
+            </a:r>
+          </a:p>
+          <a:p>
+            <a:r>
+              <a:t>Happy to go deeper on any of the six paradigms, the bound, or the specific experiments. Thank you.</a:t>
+            </a:r>
+          </a:p>
+        </p:txBody>
+      </p:sp>
+      <p:sp>
+        <p:nvSpPr>
+          <p:cNvPr id="4" name="Slide Number Placeholder 3"/>
+          <p:cNvSpPr>
+            <a:spLocks noGrp="1"/>
+          </p:cNvSpPr>
+          <p:nvPr>
+            <p:ph type="sldNum" idx="5" sz="quarter"/>
+          </p:nvPr>
+        </p:nvSpPr>
+        <p:spPr/>
+      </p:sp>
+    </p:spTree>
+  </p:cSld>
+  <p:clrMapOvr>
+    <a:masterClrMapping/>
+  </p:clrMapOvr>
+</p:notes>
 </file>
 
 <file path=ppt/slideLayouts/slideLayout1.xml><?xml version="1.0" encoding="utf-8"?>
@@ -10938,4 +12068,324 @@
   </a:objectDefaults>
   <a:extraClrSchemeLst/>
 </a:theme>
+</file>
+
+<file path=ppt/theme/theme2.xml><?xml version="1.0" encoding="utf-8"?>
+<a:theme xmlns:a="http://schemas.openxmlformats.org/drawingml/2006/main" name="Office Theme">
+  <a:themeElements>
+    <a:clrScheme name="Office">
+      <a:dk1>
+        <a:sysClr val="windowText" lastClr="000000"/>
+      </a:dk1>
+      <a:lt1>
+        <a:sysClr val="window" lastClr="FFFFFF"/>
+      </a:lt1>
+      <a:dk2>
+        <a:srgbClr val="1F497D"/>
+      </a:dk2>
+      <a:lt2>
+        <a:srgbClr val="EEECE1"/>
+      </a:lt2>
+      <a:accent1>
+        <a:srgbClr val="4F81BD"/>
+      </a:accent1>
+      <a:accent2>
+        <a:srgbClr val="C0504D"/>
+      </a:accent2>
+      <a:accent3>
+        <a:srgbClr val="9BBB59"/>
+      </a:accent3>
+      <a:accent4>
+        <a:srgbClr val="8064A2"/>
+      </a:accent4>
+      <a:accent5>
+        <a:srgbClr val="4BACC6"/>
+      </a:accent5>
+      <a:accent6>
+        <a:srgbClr val="F79646"/>
+      </a:accent6>
+      <a:hlink>
+        <a:srgbClr val="0000FF"/>
+      </a:hlink>
+      <a:folHlink>
+        <a:srgbClr val="800080"/>
+      </a:folHlink>
+    </a:clrScheme>
+    <a:fontScheme name="Office">
+      <a:majorFont>
+        <a:latin typeface="Calibri"/>
+        <a:ea typeface=""/>
+        <a:cs typeface=""/>
+        <a:font script="Jpan" typeface="ＭＳ Ｐゴシック"/>
+        <a:font script="Hang" typeface="맑은 고딕"/>
+        <a:font script="Hans" typeface="宋体"/>
+        <a:font script="Hant" typeface="新細明體"/>
+        <a:font script="Arab" typeface="Times New Roman"/>
+        <a:font script="Hebr" typeface="Times New Roman"/>
+        <a:font script="Thai" typeface="Angsana New"/>
+        <a:font script="Ethi" typeface="Nyala"/>
+        <a:font script="Beng" typeface="Vrinda"/>
+        <a:font script="Gujr" typeface="Shruti"/>
+        <a:font script="Khmr" typeface="MoolBoran"/>
+        <a:font script="Knda" typeface="Tunga"/>
+        <a:font script="Guru" typeface="Raavi"/>
+        <a:font script="Cans" typeface="Euphemia"/>
+        <a:font script="Cher" typeface="Plantagenet Cherokee"/>
+        <a:font script="Yiii" typeface="Microsoft Yi Baiti"/>
+        <a:font script="Tibt" typeface="Microsoft Himalaya"/>
+        <a:font script="Thaa" typeface="MV Boli"/>
+        <a:font script="Deva" typeface="Mangal"/>
+        <a:font script="Telu" typeface="Gautami"/>
+        <a:font script="Taml" typeface="Latha"/>
+        <a:font script="Syrc" typeface="Estrangelo Edessa"/>
+        <a:font script="Orya" typeface="Kalinga"/>
+        <a:font script="Mlym" typeface="Kartika"/>
+        <a:font script="Laoo" typeface="DokChampa"/>
+        <a:font script="Sinh" typeface="Iskoola Pota"/>
+        <a:font script="Mong" typeface="Mongolian Baiti"/>
+        <a:font script="Viet" typeface="Times New Roman"/>
+        <a:font script="Uigh" typeface="Microsoft Uighur"/>
+        <a:font script="Geor" typeface="Sylfaen"/>
+      </a:majorFont>
+      <a:minorFont>
+        <a:latin typeface="Calibri"/>
+        <a:ea typeface=""/>
+        <a:cs typeface=""/>
+        <a:font script="Jpan" typeface="ＭＳ Ｐゴシック"/>
+        <a:font script="Hang" typeface="맑은 고딕"/>
+        <a:font script="Hans" typeface="宋体"/>
+        <a:font script="Hant" typeface="新細明體"/>
+        <a:font script="Arab" typeface="Arial"/>
+        <a:font script="Hebr" typeface="Arial"/>
+        <a:font script="Thai" typeface="Cordia New"/>
+        <a:font script="Ethi" typeface="Nyala"/>
+        <a:font script="Beng" typeface="Vrinda"/>
+        <a:font script="Gujr" typeface="Shruti"/>
+        <a:font script="Khmr" typeface="DaunPenh"/>
+        <a:font script="Knda" typeface="Tunga"/>
+        <a:font script="Guru" typeface="Raavi"/>
+        <a:font script="Cans" typeface="Euphemia"/>
+        <a:font script="Cher" typeface="Plantagenet Cherokee"/>
+        <a:font script="Yiii" typeface="Microsoft Yi Baiti"/>
+        <a:font script="Tibt" typeface="Microsoft Himalaya"/>
+        <a:font script="Thaa" typeface="MV Boli"/>
+        <a:font script="Deva" typeface="Mangal"/>
+        <a:font script="Telu" typeface="Gautami"/>
+        <a:font script="Taml" typeface="Latha"/>
+        <a:font script="Syrc" typeface="Estrangelo Edessa"/>
+        <a:font script="Orya" typeface="Kalinga"/>
+        <a:font script="Mlym" typeface="Kartika"/>
+        <a:font script="Laoo" typeface="DokChampa"/>
+        <a:font script="Sinh" typeface="Iskoola Pota"/>
+        <a:font script="Mong" typeface="Mongolian Baiti"/>
+        <a:font script="Viet" typeface="Arial"/>
+        <a:font script="Uigh" typeface="Microsoft Uighur"/>
+        <a:font script="Geor" typeface="Sylfaen"/>
+      </a:minorFont>
+    </a:fontScheme>
+    <a:fmtScheme name="Office">
+      <a:fillStyleLst>
+        <a:solidFill>
+          <a:schemeClr val="phClr"/>
+        </a:solidFill>
+        <a:gradFill rotWithShape="1">
+          <a:gsLst>
+            <a:gs pos="0">
+              <a:schemeClr val="phClr">
+                <a:tint val="50000"/>
+                <a:satMod val="300000"/>
+              </a:schemeClr>
+            </a:gs>
+            <a:gs pos="35000">
+              <a:schemeClr val="phClr">
+                <a:tint val="37000"/>
+                <a:satMod val="300000"/>
+              </a:schemeClr>
+            </a:gs>
+            <a:gs pos="100000">
+              <a:schemeClr val="phClr">
+                <a:tint val="15000"/>
+                <a:satMod val="350000"/>
+              </a:schemeClr>
+            </a:gs>
+          </a:gsLst>
+          <a:lin ang="16200000" scaled="1"/>
+        </a:gradFill>
+        <a:gradFill rotWithShape="1">
+          <a:gsLst>
+            <a:gs pos="0">
+              <a:schemeClr val="phClr">
+                <a:tint val="100000"/>
+                <a:shade val="100000"/>
+                <a:satMod val="130000"/>
+              </a:schemeClr>
+            </a:gs>
+            <a:gs pos="100000">
+              <a:schemeClr val="phClr">
+                <a:tint val="50000"/>
+                <a:shade val="100000"/>
+                <a:satMod val="350000"/>
+              </a:schemeClr>
+            </a:gs>
+          </a:gsLst>
+          <a:lin ang="16200000" scaled="0"/>
+        </a:gradFill>
+      </a:fillStyleLst>
+      <a:lnStyleLst>
+        <a:ln w="9525" cap="flat" cmpd="sng" algn="ctr">
+          <a:solidFill>
+            <a:schemeClr val="phClr">
+              <a:shade val="95000"/>
+              <a:satMod val="105000"/>
+            </a:schemeClr>
+          </a:solidFill>
+          <a:prstDash val="solid"/>
+        </a:ln>
+        <a:ln w="25400" cap="flat" cmpd="sng" algn="ctr">
+          <a:solidFill>
+            <a:schemeClr val="phClr"/>
+          </a:solidFill>
+          <a:prstDash val="solid"/>
+        </a:ln>
+        <a:ln w="38100" cap="flat" cmpd="sng" algn="ctr">
+          <a:solidFill>
+            <a:schemeClr val="phClr"/>
+          </a:solidFill>
+          <a:prstDash val="solid"/>
+        </a:ln>
+      </a:lnStyleLst>
+      <a:effectStyleLst>
+        <a:effectStyle>
+          <a:effectLst>
+            <a:outerShdw blurRad="40000" dist="20000" dir="5400000" rotWithShape="0">
+              <a:srgbClr val="000000">
+                <a:alpha val="38000"/>
+              </a:srgbClr>
+            </a:outerShdw>
+          </a:effectLst>
+        </a:effectStyle>
+        <a:effectStyle>
+          <a:effectLst>
+            <a:outerShdw blurRad="40000" dist="23000" dir="5400000" rotWithShape="0">
+              <a:srgbClr val="000000">
+                <a:alpha val="35000"/>
+              </a:srgbClr>
+            </a:outerShdw>
+          </a:effectLst>
+        </a:effectStyle>
+        <a:effectStyle>
+          <a:effectLst>
+            <a:outerShdw blurRad="40000" dist="23000" dir="5400000" rotWithShape="0">
+              <a:srgbClr val="000000">
+                <a:alpha val="35000"/>
+              </a:srgbClr>
+            </a:outerShdw>
+          </a:effectLst>
+          <a:scene3d>
+            <a:camera prst="orthographicFront">
+              <a:rot lat="0" lon="0" rev="0"/>
+            </a:camera>
+            <a:lightRig rig="threePt" dir="t">
+              <a:rot lat="0" lon="0" rev="1200000"/>
+            </a:lightRig>
+          </a:scene3d>
+          <a:sp3d>
+            <a:bevelT w="63500" h="25400"/>
+          </a:sp3d>
+        </a:effectStyle>
+      </a:effectStyleLst>
+      <a:bgFillStyleLst>
+        <a:solidFill>
+          <a:schemeClr val="phClr"/>
+        </a:solidFill>
+        <a:gradFill rotWithShape="1">
+          <a:gsLst>
+            <a:gs pos="0">
+              <a:schemeClr val="phClr">
+                <a:tint val="40000"/>
+                <a:satMod val="350000"/>
+              </a:schemeClr>
+            </a:gs>
+            <a:gs pos="40000">
+              <a:schemeClr val="phClr">
+                <a:tint val="45000"/>
+                <a:shade val="99000"/>
+                <a:satMod val="350000"/>
+              </a:schemeClr>
+            </a:gs>
+            <a:gs pos="100000">
+              <a:schemeClr val="phClr">
+                <a:shade val="20000"/>
+                <a:satMod val="255000"/>
+              </a:schemeClr>
+            </a:gs>
+          </a:gsLst>
+          <a:path path="circle">
+            <a:fillToRect l="50000" t="-80000" r="50000" b="180000"/>
+          </a:path>
+        </a:gradFill>
+        <a:gradFill rotWithShape="1">
+          <a:gsLst>
+            <a:gs pos="0">
+              <a:schemeClr val="phClr">
+                <a:tint val="80000"/>
+                <a:satMod val="300000"/>
+              </a:schemeClr>
+            </a:gs>
+            <a:gs pos="100000">
+              <a:schemeClr val="phClr">
+                <a:shade val="30000"/>
+                <a:satMod val="200000"/>
+              </a:schemeClr>
+            </a:gs>
+          </a:gsLst>
+          <a:path path="circle">
+            <a:fillToRect l="50000" t="50000" r="50000" b="50000"/>
+          </a:path>
+        </a:gradFill>
+      </a:bgFillStyleLst>
+    </a:fmtScheme>
+  </a:themeElements>
+  <a:objectDefaults>
+    <a:spDef>
+      <a:spPr/>
+      <a:bodyPr/>
+      <a:lstStyle/>
+      <a:style>
+        <a:lnRef idx="1">
+          <a:schemeClr val="accent1"/>
+        </a:lnRef>
+        <a:fillRef idx="3">
+          <a:schemeClr val="accent1"/>
+        </a:fillRef>
+        <a:effectRef idx="2">
+          <a:schemeClr val="accent1"/>
+        </a:effectRef>
+        <a:fontRef idx="minor">
+          <a:schemeClr val="lt1"/>
+        </a:fontRef>
+      </a:style>
+    </a:spDef>
+    <a:lnDef>
+      <a:spPr/>
+      <a:bodyPr/>
+      <a:lstStyle/>
+      <a:style>
+        <a:lnRef idx="2">
+          <a:schemeClr val="accent1"/>
+        </a:lnRef>
+        <a:fillRef idx="0">
+          <a:schemeClr val="accent1"/>
+        </a:fillRef>
+        <a:effectRef idx="1">
+          <a:schemeClr val="accent1"/>
+        </a:effectRef>
+        <a:fontRef idx="minor">
+          <a:schemeClr val="tx1"/>
+        </a:fontRef>
+      </a:style>
+    </a:lnDef>
+  </a:objectDefaults>
+  <a:extraClrSchemeLst/>
+</a:theme>
 </file>
</xml_diff>

<commit_message>
talk: more detailed speaker notes (beyond_attention_paradigms.pptx)
</commit_message>
<xml_diff>
--- a/talk/beyond_attention_paradigms.pptx
+++ b/talk/beyond_attention_paradigms.pptx
@@ -510,17 +510,25 @@
           <a:lstStyle/>
           <a:p>
             <a:r>
-              <a:t>[~30s · open calm, set the frame]</a:t>
-            </a:r>
-          </a:p>
-          <a:p>
-            <a:r>
-              <a:t>Thanks for the time. I want to walk through a research direction that came out of a small empirical result of mine -- a short paper called "The Sparsity Ceiling."</a:t>
-            </a:r>
-          </a:p>
-          <a:p>
-            <a:r>
-              <a:t>One-line version: if spiking, brain-inspired hardware cannot ride the Transformer paradigm -- and I'll show you it structurally can't -- then the real question is what paradigm of intelligence it CAN ride. Today I map six candidates and say where I'd place the bet.</a:t>
+              <a:t>[~40s · open calm, set the frame]</a:t>
+            </a:r>
+          </a:p>
+          <a:p/>
+          <a:p>
+            <a:r>
+              <a:t>SAY: Thanks for the time. This is a research direction that grew out of a small empirical result of mine -- a short paper, "The Sparsity Ceiling," now on arXiv under cs.NE. The one-line version: if spiking, brain-inspired hardware cannot ride the Transformer paradigm -- and I have a result showing it structurally can't -- then the real question isn't "how do we port Transformers to neuromorphic," it's "what paradigm of intelligence is neuromorphic actually FOR." Today I'll give you the argument, a map of six non-attention paradigms, and where I'd place the bet -- ending on four concrete projects.</a:t>
+            </a:r>
+          </a:p>
+          <a:p/>
+          <a:p>
+            <a:r>
+              <a:t>HAVE READY: The paper is my own work -- controlled experiments on an 8xA800 box, plus a small information-theoretic bound. Everything I show is either that result or peer-reviewed 2024-26 literature.</a:t>
+            </a:r>
+          </a:p>
+          <a:p/>
+          <a:p>
+            <a:r>
+              <a:t>DELIVERY: Don't rush the title. Let "what is neuromorphic FOR" sit for a beat -- that's the whole talk.</a:t>
             </a:r>
           </a:p>
         </p:txBody>
@@ -590,22 +598,31 @@
           <a:lstStyle/>
           <a:p>
             <a:r>
-              <a:t>[~60s · this is the thesis slide -- slow down]</a:t>
-            </a:r>
-          </a:p>
-          <a:p>
-            <a:r>
-              <a:t>Start with what I think intelligence actually is. My working definition: a predictive generative model of the world, held in ongoing dynamics, that spends compute only on surprise and acts to test its own predictions. The key word is LOOP -- model interacting with world -- not a function that maps context to a token.</a:t>
-            </a:r>
-          </a:p>
+              <a:t>[~70s · this is the thesis slide -- slow down, this is the frame everything hangs on]</a:t>
+            </a:r>
+          </a:p>
+          <a:p/>
+          <a:p>
+            <a:r>
+              <a:t>SAY: Start with what I think intelligence actually is. My working definition: a predictive generative model of the world, held in ongoing internal dynamics, that spends compute only on surprise, and acts to test its own predictions. The operative word is LOOP -- a system continuously interacting with the world -- not a FUNCTION that maps a context window to a token. That distinction is architectural, not philosophical: a Transformer has no persistent internal state between calls; every forward pass is independent, and its "memory" is just the context re-fed each time. A brain never restarts -- it's a continuous dynamical system whose core operation is to predict incoming signals and propagate only the residual error. That's predictive coding -- Rao and Ballard '99, formalized by Friston's free-energy principle.</a:t>
+            </a:r>
+          </a:p>
+          <a:p/>
           <a:p>
             <a:r>
               <a:t>Transformers reach intelligence the opposite way: stateless, dense retrieval over the entire context, brute-forced with scale.</a:t>
             </a:r>
           </a:p>
-          <a:p>
-            <a:r>
-              <a:t>On the right is my empirical hook. In the sparsity-ceiling work, a recurrent spiking net hits a hard firing floor around 50% -- you cannot make it sparse. Attention CAN be made sparse, but only by storing the full key-value cache -- an O(context) memory wall. Either way, the Transformer route is mismatched to neuromorphic hardware. That mismatch is what motivates the whole talk.</a:t>
+          <a:p/>
+          <a:p>
+            <a:r>
+              <a:t>Now the empirical hook, on the right -- my result. Same network, swap only the neuron. A recurrent spiking net hits a hard firing floor around 50 percent: even with a strong sparsity penalty targeting 10 percent, three seeds, it will not go below ~50. Attention CAN be driven sparse -- I get a spiking Transformer down to 2 percent firing -- but only because it stores the full key-value cache, which is O(context) memory. So on neuromorphic hardware you face a dichotomy: recurrence pays a firing floor, attention pays a memory wall. Either way, the Transformer route is mismatched to the hardware. That mismatch is what motivates the entire talk.</a:t>
+            </a:r>
+          </a:p>
+          <a:p/>
+          <a:p>
+            <a:r>
+              <a:t>IF ASKED "isn't next-token prediction also prediction?": Yes, but it's prediction implemented as a global retrieval over a stored context in one dense pass -- not prediction as an ongoing generative model with error feedback and persistent latent state. The residual-only, stateful version is what's cheap on neuromorphic; the retrieval version is what's expensive.</a:t>
             </a:r>
           </a:p>
         </p:txBody>
@@ -675,17 +692,50 @@
           <a:lstStyle/>
           <a:p>
             <a:r>
-              <a:t>[~45s · walk the last row hard]</a:t>
-            </a:r>
-          </a:p>
-          <a:p>
-            <a:r>
-              <a:t>Side by side, the two paradigms are almost point-for-point opposites. Transformer: stateless, external memory that grows with context, dense all-pairs compute, offline global backprop, intelligence from scale. Brain: persistent state, memory compressed into the state and synapses, compute spent only on prediction error, local online learning, intelligence from prediction and action.</a:t>
-            </a:r>
-          </a:p>
-          <a:p>
-            <a:r>
-              <a:t>The bottom row is the punchline for us: the Transformer column is exactly what neuromorphic hardware is bad at -- dense MACs and a memory wall -- and the brain column is exactly what it is good at -- event-driven, analog, local. So the paradigm choice and the hardware choice are the same choice.</a:t>
+              <a:t>[~55s · walk each row briefly, hit the bottom row hard]</a:t>
+            </a:r>
+          </a:p>
+          <a:p/>
+          <a:p>
+            <a:r>
+              <a:t>SAY: Side by side, the two paradigms are almost point-for-point opposites.</a:t>
+            </a:r>
+          </a:p>
+          <a:p>
+            <a:r>
+              <a:t>- State: a Transformer is a pure function of its input window; the brain is a stateful dynamical system -- attractors, oscillations, persistent activity.</a:t>
+            </a:r>
+          </a:p>
+          <a:p>
+            <a:r>
+              <a:t>- Memory: the KV cache grows linearly with context -- that's the memory wall. On-chip SRAM is tiny -- IBM's NorthPole is 224 megabytes; it can't even hold LLM weights, let alone a growing cache. The brain compresses history into a fixed-dimensional state plus synaptic weights.</a:t>
+            </a:r>
+          </a:p>
+          <a:p>
+            <a:r>
+              <a:t>- Compute: attention is O(L-squared) all-pairs, QK-transpose over everything. Predictive coding computes only on prediction errors -- sparse by construction.</a:t>
+            </a:r>
+          </a:p>
+          <a:p>
+            <a:r>
+              <a:t>- Learning: backprop needs a global error signal and stored activations for the whole graph; the brain uses local, Hebbian, three-factor rules -- online and continual.</a:t>
+            </a:r>
+          </a:p>
+          <a:p>
+            <a:r>
+              <a:t>- Source of capability: Transformers get it from scale -- parameters times data times compute; the brain from a good generative model plus embodiment.</a:t>
+            </a:r>
+          </a:p>
+          <a:p/>
+          <a:p>
+            <a:r>
+              <a:t>The bottom row is the punchline for us: the Transformer column is precisely what neuromorphic hardware is BAD at -- dense MACs and a memory wall -- and the brain column is precisely what it's GOOD at -- event-driven, analog, local. So the paradigm choice and the hardware choice are the same choice. You don't pick the hardware and then port the algorithm; you pick the paradigm the physics wants.</a:t>
+            </a:r>
+          </a:p>
+          <a:p/>
+          <a:p>
+            <a:r>
+              <a:t>IF ASKED "Transformers work today and brain-like models don't -- so what?": Fair, and I'll be honest about that on slide 7. This slide is about structural alignment with the hardware, not current capability.</a:t>
             </a:r>
           </a:p>
         </p:txBody>
@@ -755,22 +805,52 @@
           <a:lstStyle/>
           <a:p>
             <a:r>
-              <a:t>[~55s · anticipate the obvious objection]</a:t>
-            </a:r>
-          </a:p>
-          <a:p>
-            <a:r>
-              <a:t>Here's the fair objection: my own paper proves recurrent spiking nets have a firing floor. So how does the brain -- which is recurrent and spiking -- avoid it?</a:t>
-            </a:r>
-          </a:p>
-          <a:p>
-            <a:r>
-              <a:t>Because the brain violates the assumption behind my bound. My bound assumes information travels ONLY in spikes. The brain doesn't. It holds memory in sub-threshold membrane potential and short-term synaptic state -- activity-silent -- and spikes only to signal errors. That escapes the firing floor AND the memory wall at once. Add an enormous neuron count, which pushes the required firing rate toward zero, and local multi-timescale learning.</a:t>
-            </a:r>
-          </a:p>
-          <a:p>
-            <a:r>
-              <a:t>The takeaway is the line at the bottom: the brain is an existence proof -- general intelligence at 20 watts, about a thousand times more efficient than GPUs -- using prediction and sparsity, not attention.</a:t>
+              <a:t>[~65s · anticipate the obvious objection -- this is the intellectually strongest slide]</a:t>
+            </a:r>
+          </a:p>
+          <a:p/>
+          <a:p>
+            <a:r>
+              <a:t>SAY: Here's the fair objection, and I want to meet it head-on: my own paper proves recurrent spiking nets have a firing floor. So how does the brain -- which is recurrent AND spiking -- avoid it?</a:t>
+            </a:r>
+          </a:p>
+          <a:p/>
+          <a:p>
+            <a:r>
+              <a:t>The answer: the brain violates the assumption behind my bound. My bound says the minimum firing rate rho is at least H-b-inverse of log-2 M over H -- it comes from a counting argument: a binary vector of H units with rho-H ones can only index about 2-to-the-(H times binary-entropy-of-rho) distinct states, so to hold M memories you need enough active bits. But that bound assumes the state channel is BINARY SPIKES. The brain's isn't.</a:t>
+            </a:r>
+          </a:p>
+          <a:p/>
+          <a:p>
+            <a:r>
+              <a:t>Three escapes:</a:t>
+            </a:r>
+          </a:p>
+          <a:p>
+            <a:r>
+              <a:t>One -- analog state. Real neurons carry graded information in sub-threshold membrane potential, and hold working memory in short-term synaptic facilitation -- "activity-silent" memory, Mongillo '08, Stokes '15. Memory can persist with near-zero firing. So spikes aren't the memory channel; they signal errors.</a:t>
+            </a:r>
+          </a:p>
+          <a:p>
+            <a:r>
+              <a:t>Two -- enormous H. Ten-to-the-eleven neurons drives log-2 M over H toward zero, so rho-min goes to zero. Sparse coding, roughly one-to-two percent active, is exactly the observed regime.</a:t>
+            </a:r>
+          </a:p>
+          <a:p>
+            <a:r>
+              <a:t>Three -- local, multi-timescale learning: fast spikes, slow synaptic eligibility traces, neuromodulation as the third factor. No unrolling the whole history.</a:t>
+            </a:r>
+          </a:p>
+          <a:p/>
+          <a:p>
+            <a:r>
+              <a:t>The bottom line is the existence proof: the brain runs general intelligence on 20 watts -- about a thousand times more efficient than GPUs per equivalent operation -- using prediction and sparsity, not attention. So the paradigm demonstrably scales to general intelligence. That's the whole reason to take it seriously.</a:t>
+            </a:r>
+          </a:p>
+          <a:p/>
+          <a:p>
+            <a:r>
+              <a:t>IF ASKED "so just build analog neurons?": Essentially yes -- that's my direction #1, an analog-state SSM. The bet is analog state plus event-driven spikes, not spiking Transformers.</a:t>
             </a:r>
           </a:p>
         </p:txBody>
@@ -840,47 +920,56 @@
           <a:lstStyle/>
           <a:p>
             <a:r>
-              <a:t>[~70s · this is the survey -- keep it brisk, one breath per row]</a:t>
-            </a:r>
-          </a:p>
-          <a:p>
-            <a:r>
-              <a:t>So if not attention, what? Six non-attention paradigms, each a real, active line of work.</a:t>
-            </a:r>
-          </a:p>
-          <a:p>
-            <a:r>
-              <a:t>Predictive coding -- hierarchical error propagation, local learning that provably approximates backprop.</a:t>
-            </a:r>
-          </a:p>
-          <a:p>
-            <a:r>
-              <a:t>Equilibrium propagation -- energy-based, local weight updates, analog-native, with hardware demos claiming four orders of magnitude less training energy.</a:t>
-            </a:r>
-          </a:p>
-          <a:p>
-            <a:r>
-              <a:t>Analog and spiking state-space models -- linear recurrence, no KV cache; keep the state in analog dynamics and you sidestep the firing floor.</a:t>
-            </a:r>
-          </a:p>
-          <a:p>
-            <a:r>
-              <a:t>World models and JEPA -- predict in latent space, plan by simulation.</a:t>
-            </a:r>
-          </a:p>
-          <a:p>
-            <a:r>
-              <a:t>Modern Hopfield / associative memory -- and this one is delightful: a Hopfield read is mathematically identical to attention, so the brain's "attention" is attractor dynamics, not QK-transpose.</a:t>
-            </a:r>
-          </a:p>
-          <a:p>
-            <a:r>
-              <a:t>Active inference -- minimize expected surprise in a perception-action loop.</a:t>
-            </a:r>
-          </a:p>
-          <a:p>
-            <a:r>
-              <a:t>The double checkmarks are where neuromorphic physics is an actual advantage, not just an algorithmic fit.</a:t>
+              <a:t>[~80s · the survey -- keep brisk, roughly one breath per row; you don't need every citation aloud, have them ready]</a:t>
+            </a:r>
+          </a:p>
+          <a:p/>
+          <a:p>
+            <a:r>
+              <a:t>SAY: If not attention, what? Six non-attention paradigms, each a real, active line.</a:t>
+            </a:r>
+          </a:p>
+          <a:p/>
+          <a:p>
+            <a:r>
+              <a:t>- Predictive coding: a hierarchy where each layer predicts the one below and only errors propagate; the learning rule is local yet provably approximates backprop -- Whittington and Bogacz, Millidge et al. 2022, and a stable fast version at ICLR 2024.</a:t>
+            </a:r>
+          </a:p>
+          <a:p>
+            <a:r>
+              <a:t>- Equilibrium propagation: energy-based; you relax the network to an energy minimum, nudge the output, and the weight update falls out of the local activity difference -- no separate backward pass. It's analog-native; hardware demos on memristors and oscillators claim up to four orders of magnitude less training energy, and there's now ImageNet-scale EP.</a:t>
+            </a:r>
+          </a:p>
+          <a:p>
+            <a:r>
+              <a:t>- Analog and spiking state-space models: SSMs -- S4, then Mamba -- are the anti-Transformer sequence model: linear recurrence, compressed state, O(L), no KV cache. Spiking versions -- SpikingMamba, SpikySpace -- add event-driven sparsity; if you keep the state analog you sidestep my firing floor.</a:t>
+            </a:r>
+          </a:p>
+          <a:p>
+            <a:r>
+              <a:t>- World models and JEPA: LeCun's bet -- predict in latent representation space, not pixels or tokens; V-JEPA 2 is 1.2 billion parameters on a million hours of video. Pair it with model-based planning -- Dreamer, MuZero -- and reasoning becomes simulation and search, not one dense pass.</a:t>
+            </a:r>
+          </a:p>
+          <a:p>
+            <a:r>
+              <a:t>- Modern Hopfield / associative memory: and this one is delightful -- Ramsauer et al. showed the modern Hopfield update is mathematically IDENTICAL to Transformer attention, with exponential storage capacity. So "attention" is just associative retrieval; the brain does the same thing with attractor relaxation dynamics -- which is neuromorphic-native.</a:t>
+            </a:r>
+          </a:p>
+          <a:p>
+            <a:r>
+              <a:t>- Active inference: minimize expected free energy; perception and action unified in one closed loop; embodied.</a:t>
+            </a:r>
+          </a:p>
+          <a:p/>
+          <a:p>
+            <a:r>
+              <a:t>The double-checkmarks are where neuromorphic PHYSICS is the enabler, not just an algorithmic fit -- predictive coding, EqProp, analog SSM.</a:t>
+            </a:r>
+          </a:p>
+          <a:p/>
+          <a:p>
+            <a:r>
+              <a:t>IF ASKED "which is closest to working at scale?": SSMs -- Mamba is already competitive with Transformers and runs on GPU. But predictive coding and EqProp are where neuromorphic hardware adds the most, because their local, error-only structure is what the silicon wants.</a:t>
             </a:r>
           </a:p>
         </p:txBody>
@@ -950,17 +1039,31 @@
           <a:lstStyle/>
           <a:p>
             <a:r>
-              <a:t>[~50s · commit -- say it like a conviction]</a:t>
-            </a:r>
-          </a:p>
-          <a:p>
-            <a:r>
-              <a:t>If I have to place the bet, it's this: a predictive world-model held in analog recurrent dynamics, learned locally and online -- predictive coding or equilibrium propagation -- acting in a closed loop, where spikes carry only surprise.</a:t>
-            </a:r>
-          </a:p>
-          <a:p>
-            <a:r>
-              <a:t>I want to stress this is not settling for less. It's choosing the paradigm where the hardware's physics is a feature, not a bug. Analog state escapes both the memory wall and the firing floor. Error-only propagation IS event-driven -- native to spiking silicon. Local plasticity means learning on-chip, no global backprop. And recurrence plus search gives you test-time reasoning without a giant single forward pass.</a:t>
+              <a:t>[~55s · commit -- say it like a conviction, not a hedge]</a:t>
+            </a:r>
+          </a:p>
+          <a:p/>
+          <a:p>
+            <a:r>
+              <a:t>SAY: If I have to place one bet, it's this: a predictive world-model held in analog recurrent dynamics, learned locally and online -- predictive coding or equilibrium propagation -- acting in a closed loop, where spikes carry only surprise.</a:t>
+            </a:r>
+          </a:p>
+          <a:p/>
+          <a:p>
+            <a:r>
+              <a:t>It's a synthesis, deliberately: SSM-style compressed recurrent state, but in analog dynamics so you escape the floor; predictive-coding error-only propagation so it's event-driven; local learning so training happens on-chip; and a world-model-plus-planning loop so reasoning is search, not a giant forward pass. Each piece has independent evidence; the claim is they compose into a coherent, neuromorphic-native stack.</a:t>
+            </a:r>
+          </a:p>
+          <a:p/>
+          <a:p>
+            <a:r>
+              <a:t>And I want to stress: this is not settling for less. It's choosing the paradigm where the hardware's physics is a feature, not a bug. The four alignment points map one-to-one onto four hardware advantages: analog state removes the memory wall AND the firing floor; error-only propagation IS event-driven, native to spiking silicon; local plasticity gives you on-chip learning at roughly ten-thousand-fold lower energy; and recurrence plus search gives you test-time reasoning without scaling a single dense pass.</a:t>
+            </a:r>
+          </a:p>
+          <a:p/>
+          <a:p>
+            <a:r>
+              <a:t>IF ASKED "isn't this just a wish-list of everything brain-like?": No -- it's specifically the subset where the physics is the enabler. I'm explicitly NOT betting on spiking Transformers or datacenter neuromorphic -- my paper shows those lose. The unifying principle is one sentence: spend energy only on surprise, and keep state in physics, not in a cache.</a:t>
             </a:r>
           </a:p>
         </p:txBody>
@@ -1030,17 +1133,25 @@
           <a:lstStyle/>
           <a:p>
             <a:r>
-              <a:t>[~45s · say the hard part plainly -- this earns credibility]</a:t>
-            </a:r>
-          </a:p>
-          <a:p>
-            <a:r>
-              <a:t>Let me be honest about where this stands. None of these paradigms has beaten Transformers yet. Predictive coding, EqProp, SSMs, Hopfield, JEPA, active inference -- all promising, all more brain-like, none has produced GPT-class general capability. This is a research bet, not a finished alternative, and I'll state it as such.</a:t>
-            </a:r>
-          </a:p>
-          <a:p>
-            <a:r>
-              <a:t>But here's why it's still the right bet: the brain runs general intelligence on 20 watts using exactly this paradigm. So we know the paradigm CAN get there -- we just haven't reproduced it. That gap is the open frontier, and it is the reason to work on it, not the reason to avoid it.</a:t>
+              <a:t>[~50s · say the hard part plainly -- this slide earns you the most credibility]</a:t>
+            </a:r>
+          </a:p>
+          <a:p/>
+          <a:p>
+            <a:r>
+              <a:t>SAY: Let me be honest about where this stands, because a professor will ask anyway. None of these paradigms has beaten Transformers yet. Predictive coding, EqProp, SSMs, Hopfield, JEPA, active inference -- all promising, all more brain-like, none has produced GPT-class general capability. Concretely, Transformers still win on three things: the scalability of backprop-on-GPUs for training, in-context learning via massive retrieval, and sheer engineering maturity. This is a research bet, not a finished alternative, and I'll state it as such.</a:t>
+            </a:r>
+          </a:p>
+          <a:p/>
+          <a:p>
+            <a:r>
+              <a:t>But here's why it's still the right bet. The brain runs general intelligence on 20 watts using exactly this paradigm. So we KNOW the paradigm can reach general intelligence -- it's an existence proof -- we just haven't reproduced it in silicon. That gap is the open frontier, and it's the reason to work on it, not the reason to avoid it.</a:t>
+            </a:r>
+          </a:p>
+          <a:p/>
+          <a:p>
+            <a:r>
+              <a:t>IF ASKED "why would this ever beat Transformers?": Two forcing functions. The energy wall -- Transformer training and inference cost is becoming unsustainable, and the brain shows a thousand-fold headroom exists. And the memory wall -- attention's KV cache doesn't scale to long-horizon, always-on agents. If either bites hard, the predictive-sparse paradigm is where the escape is.</a:t>
             </a:r>
           </a:p>
         </p:txBody>
@@ -1110,37 +1221,49 @@
           <a:lstStyle/>
           <a:p>
             <a:r>
-              <a:t>[~55s · concrete -- this is what you'd actually do in the lab]</a:t>
-            </a:r>
-          </a:p>
-          <a:p>
-            <a:r>
-              <a:t>Concretely, four things I'd work on.</a:t>
-            </a:r>
-          </a:p>
-          <a:p>
-            <a:r>
-              <a:t>One: build a state-space model whose recurrent state lives in analog sub-threshold dynamics rather than spikes, and test directly whether it breaks my bound's assumption and sparsifies the way attention did.</a:t>
-            </a:r>
-          </a:p>
-          <a:p>
-            <a:r>
-              <a:t>Two: implement predictive coding on neuromorphic silicon with local equilibrium-propagation learning, and measure real energy on Loihi 2 or SpiNNaker2 -- turning my 45-nanometer proxy into an actual measurement.</a:t>
-            </a:r>
-          </a:p>
-          <a:p>
-            <a:r>
-              <a:t>Three: formalize the recurrence-versus-attention, firing-floor-versus-memory-wall trade-off as a conservation law, and find where analog-state models sit on that frontier.</a:t>
-            </a:r>
-          </a:p>
-          <a:p>
-            <a:r>
-              <a:t>Four: a closed-loop predictive world-model for a low-power embodied agent, where neuromorphic's real-time, event-driven physics is decisive.</a:t>
-            </a:r>
-          </a:p>
-          <a:p>
-            <a:r>
-              <a:t>Any of these is a first project; the first two I could start now.</a:t>
+              <a:t>[~65s · concrete -- this is what you'd actually do in the lab; sequence it]</a:t>
+            </a:r>
+          </a:p>
+          <a:p/>
+          <a:p>
+            <a:r>
+              <a:t>SAY: Concretely, four projects.</a:t>
+            </a:r>
+          </a:p>
+          <a:p/>
+          <a:p>
+            <a:r>
+              <a:t>One -- escape the firing floor with analog state. Build a state-space model whose recurrent state is a leaky ANALOG variable, sub-threshold, with spikes only for output and error. Then measure attainable firing versus the spiking RNN: does it break my bound's assumption and sparsify the way attention did? This is the cleanest test of the core hypothesis, and I can start it in simulation today.</a:t>
+            </a:r>
+          </a:p>
+          <a:p/>
+          <a:p>
+            <a:r>
+              <a:t>Two -- predictive coding on neuromorphic silicon. Implement an error-propagating hierarchy trained with equilibrium propagation -- local rules -- and MEASURE real energy on Loihi 2 or SpiNNaker2. That turns my 45-nanometer proxy into an actual hardware measurement. This one needs INRC access to Loihi, which the PhD provides.</a:t>
+            </a:r>
+          </a:p>
+          <a:p/>
+          <a:p>
+            <a:r>
+              <a:t>Three -- formalize the trade-off. Prove the recurrence-versus-attention, firing-floor-versus-memory-wall dichotomy as a conservation law -- a Pareto frontier -- and locate where analog-state models sit on it. This is the theory contribution; it extends the paper.</a:t>
+            </a:r>
+          </a:p>
+          <a:p/>
+          <a:p>
+            <a:r>
+              <a:t>Four -- closed-loop world-model at the edge. A predictive world-model plus planning loop for a low-power embodied agent, where real-time, event-driven perception-action is decisive. This is the applied payoff.</a:t>
+            </a:r>
+          </a:p>
+          <a:p/>
+          <a:p>
+            <a:r>
+              <a:t>SEQUENCING: One and three I can start immediately -- simulation and theory. Two needs hardware access. Four is the longer applied arc.</a:t>
+            </a:r>
+          </a:p>
+          <a:p/>
+          <a:p>
+            <a:r>
+              <a:t>IF ASKED "which first?": Number one -- it directly tests whether analog state is the escape route, and it needs nothing but simulation to get the first signal.</a:t>
             </a:r>
           </a:p>
         </p:txBody>
@@ -1210,17 +1333,25 @@
           <a:lstStyle/>
           <a:p>
             <a:r>
-              <a:t>[~25s · land it, then open for questions]</a:t>
-            </a:r>
-          </a:p>
-          <a:p>
-            <a:r>
-              <a:t>To close: intelligence is a loop, not a lookup. If neuromorphic hardware can't ride attention, it shouldn't try -- its physics aligns with the predictive, sparse, local, embodied paradigm that the brain already proves works at 20 watts. That's the direction I want to pursue.</a:t>
-            </a:r>
-          </a:p>
-          <a:p>
-            <a:r>
-              <a:t>Happy to go deeper on any of the six paradigms, the bound, or the specific experiments. Thank you.</a:t>
+              <a:t>[~30s · land it, then open the floor]</a:t>
+            </a:r>
+          </a:p>
+          <a:p/>
+          <a:p>
+            <a:r>
+              <a:t>SAY: To close: intelligence is a loop, not a lookup. If neuromorphic hardware can't ride attention, it shouldn't try -- its physics aligns with the predictive, sparse, local, embodied paradigm that the brain already proves works at 20 watts. That alignment is the thesis, and those four projects are how I'd pursue it.</a:t>
+            </a:r>
+          </a:p>
+          <a:p/>
+          <a:p>
+            <a:r>
+              <a:t>I'm happy to go deeper on any of the six paradigms, on the bound and its derivation, or on the experiments. Thank you.</a:t>
+            </a:r>
+          </a:p>
+          <a:p/>
+          <a:p>
+            <a:r>
+              <a:t>HAVE READY FOR Q&amp;A: the arXiv paper; the bound's one-line derivation (counting argument); and the six key citations on the sources slide.</a:t>
             </a:r>
           </a:p>
         </p:txBody>

</xml_diff>

<commit_message>
talk: regenerate deck to post-retraction SSM framing (new results slide, bound annotated, directions renumbered)
New slide 08 reports the finished analog-state SSM study: 1.60x proxy-energy cut
for +0.160 bpc with 'analog beats digital' explicitly retracted, the workload
inversion with copy margins quoted vs the noise-regularized reference, the
datapath-degradation principle with its post-hoc label, and the firing-floor
bound reported as a negative (12x floor swing vs rho falling 0.496->0.250).
Patch is a committed re-runnable script that aborts on any missing text anchor;
it also clones the slide-level p:bg the cloned slide would otherwise lose.
PDF rebuilt locally (server has no LibreOffice), verified at 10 pages.

Co-Authored-By: Claude Fable 5 <noreply@anthropic.com>
</commit_message>
<xml_diff>
--- a/talk/beyond_attention_paradigms.pptx
+++ b/talk/beyond_attention_paradigms.pptx
@@ -12,6 +12,7 @@
     <p:sldId id="260" r:id="rId11"/>
     <p:sldId id="261" r:id="rId12"/>
     <p:sldId id="262" r:id="rId13"/>
+    <p:sldId id="265" r:id="rId17"/>
     <p:sldId id="263" r:id="rId14"/>
     <p:sldId id="264" r:id="rId15"/>
   </p:sldIdLst>
@@ -4611,6 +4612,848 @@
 </p:sld>
 </file>
 
+<file path=ppt/slides/slide10.xml><?xml version="1.0" encoding="utf-8"?>
+<p:sld xmlns:a="http://schemas.openxmlformats.org/drawingml/2006/main" xmlns:p="http://schemas.openxmlformats.org/presentationml/2006/main" xmlns:r="http://schemas.openxmlformats.org/officeDocument/2006/relationships">
+  <p:cSld>
+    <p:bg>
+      <p:bgPr>
+        <a:solidFill>
+          <a:srgbClr val="0C1015"/>
+        </a:solidFill>
+        <a:effectLst/>
+      </p:bgPr>
+    </p:bg>
+    <p:spTree>
+      <p:nvGrpSpPr>
+        <p:cNvPr id="1" name=""/>
+        <p:cNvGrpSpPr/>
+        <p:nvPr/>
+      </p:nvGrpSpPr>
+      <p:grpSpPr/>
+      <p:sp>
+        <p:nvSpPr>
+          <p:cNvPr id="2" name="TextBox 1"/>
+          <p:cNvSpPr txBox="1"/>
+          <p:nvPr/>
+        </p:nvSpPr>
+        <p:spPr>
+          <a:xfrm>
+            <a:off x="548640" y="457200"/>
+            <a:ext cx="10972800" cy="274320"/>
+          </a:xfrm>
+          <a:prstGeom prst="rect">
+            <a:avLst/>
+          </a:prstGeom>
+          <a:noFill/>
+        </p:spPr>
+        <p:txBody>
+          <a:bodyPr wrap="square" anchor="t" lIns="0" rIns="0" tIns="0" bIns="0">
+            <a:spAutoFit/>
+          </a:bodyPr>
+          <a:lstStyle/>
+          <a:p>
+            <a:pPr algn="l">
+              <a:lnSpc>
+                <a:spcPct val="105000"/>
+              </a:lnSpc>
+            </a:pPr>
+            <a:r>
+              <a:rPr sz="1150" b="1" spc="140">
+                <a:solidFill>
+                  <a:srgbClr val="25C6D2"/>
+                </a:solidFill>
+                <a:latin typeface="Consolas"/>
+              </a:rPr>
+              <a:t>07 · SSM RESULTS</a:t>
+            </a:r>
+          </a:p>
+        </p:txBody>
+      </p:sp>
+      <p:sp>
+        <p:nvSpPr>
+          <p:cNvPr id="3" name="TextBox 2"/>
+          <p:cNvSpPr txBox="1"/>
+          <p:nvPr/>
+        </p:nvSpPr>
+        <p:spPr>
+          <a:xfrm>
+            <a:off x="548640" y="6400800"/>
+            <a:ext cx="8229600" cy="274320"/>
+          </a:xfrm>
+          <a:prstGeom prst="rect">
+            <a:avLst/>
+          </a:prstGeom>
+          <a:noFill/>
+        </p:spPr>
+        <p:txBody>
+          <a:bodyPr wrap="square" anchor="t" lIns="0" rIns="0" tIns="0" bIns="0">
+            <a:spAutoFit/>
+          </a:bodyPr>
+          <a:lstStyle/>
+          <a:p>
+            <a:pPr algn="l">
+              <a:lnSpc>
+                <a:spcPct val="105000"/>
+              </a:lnSpc>
+            </a:pPr>
+            <a:r>
+              <a:rPr sz="850" b="0" spc="110">
+                <a:solidFill>
+                  <a:srgbClr val="667280"/>
+                </a:solidFill>
+                <a:latin typeface="Consolas"/>
+              </a:rPr>
+              <a:t>BEYOND ATTENTION · NEUROMORPHIC INTELLIGENCE PARADIGMS</a:t>
+            </a:r>
+          </a:p>
+        </p:txBody>
+      </p:sp>
+      <p:sp>
+        <p:nvSpPr>
+          <p:cNvPr id="4" name="TextBox 3"/>
+          <p:cNvSpPr txBox="1"/>
+          <p:nvPr/>
+        </p:nvSpPr>
+        <p:spPr>
+          <a:xfrm>
+            <a:off x="10911535" y="6400800"/>
+            <a:ext cx="731520" cy="274320"/>
+          </a:xfrm>
+          <a:prstGeom prst="rect">
+            <a:avLst/>
+          </a:prstGeom>
+          <a:noFill/>
+        </p:spPr>
+        <p:txBody>
+          <a:bodyPr wrap="square" anchor="t" lIns="0" rIns="0" tIns="0" bIns="0">
+            <a:spAutoFit/>
+          </a:bodyPr>
+          <a:lstStyle/>
+          <a:p>
+            <a:pPr algn="r">
+              <a:lnSpc>
+                <a:spcPct val="105000"/>
+              </a:lnSpc>
+            </a:pPr>
+            <a:r>
+              <a:rPr sz="850" b="0">
+                <a:solidFill>
+                  <a:srgbClr val="667280"/>
+                </a:solidFill>
+                <a:latin typeface="Consolas"/>
+              </a:rPr>
+              <a:t>08</a:t>
+            </a:r>
+          </a:p>
+        </p:txBody>
+      </p:sp>
+      <p:sp>
+        <p:nvSpPr>
+          <p:cNvPr id="5" name="TextBox 4"/>
+          <p:cNvSpPr txBox="1"/>
+          <p:nvPr/>
+        </p:nvSpPr>
+        <p:spPr>
+          <a:xfrm>
+            <a:off x="548640" y="822960"/>
+            <a:ext cx="10972800" cy="548640"/>
+          </a:xfrm>
+          <a:prstGeom prst="rect">
+            <a:avLst/>
+          </a:prstGeom>
+          <a:noFill/>
+        </p:spPr>
+        <p:txBody>
+          <a:bodyPr wrap="square" anchor="t" lIns="0" rIns="0" tIns="0" bIns="0">
+            <a:spAutoFit/>
+          </a:bodyPr>
+          <a:lstStyle/>
+          <a:p>
+            <a:pPr algn="l">
+              <a:lnSpc>
+                <a:spcPct val="105000"/>
+              </a:lnSpc>
+            </a:pPr>
+            <a:r>
+              <a:rPr sz="2400" b="1">
+                <a:solidFill>
+                  <a:srgbClr val="E7ECF2"/>
+                </a:solidFill>
+                <a:latin typeface="Arial"/>
+              </a:rPr>
+              <a:t>Direction One, run: what the analog-state SSM actually did</a:t>
+            </a:r>
+          </a:p>
+        </p:txBody>
+      </p:sp>
+      <p:sp>
+        <p:nvSpPr>
+          <p:cNvPr id="6" name="Rounded Rectangle 5"/>
+          <p:cNvSpPr/>
+          <p:nvPr/>
+        </p:nvSpPr>
+        <p:spPr>
+          <a:xfrm>
+            <a:off x="548640" y="1645920"/>
+            <a:ext cx="5440680" cy="1691640"/>
+          </a:xfrm>
+          <a:prstGeom prst="roundRect">
+            <a:avLst>
+              <a:gd name="adj" fmla="val 8000"/>
+            </a:avLst>
+          </a:prstGeom>
+          <a:solidFill>
+            <a:srgbClr val="161C24"/>
+          </a:solidFill>
+          <a:ln w="12700">
+            <a:solidFill>
+              <a:srgbClr val="2A3440"/>
+            </a:solidFill>
+          </a:ln>
+          <a:effectLst/>
+        </p:spPr>
+        <p:style>
+          <a:lnRef idx="1">
+            <a:schemeClr val="accent1"/>
+          </a:lnRef>
+          <a:fillRef idx="3">
+            <a:schemeClr val="accent1"/>
+          </a:fillRef>
+          <a:effectRef idx="2">
+            <a:schemeClr val="accent1"/>
+          </a:effectRef>
+          <a:fontRef idx="minor">
+            <a:schemeClr val="lt1"/>
+          </a:fontRef>
+        </p:style>
+        <p:txBody>
+          <a:bodyPr rtlCol="0" anchor="ctr"/>
+          <a:lstStyle/>
+          <a:p>
+            <a:pPr algn="ctr"/>
+          </a:p>
+        </p:txBody>
+      </p:sp>
+      <p:sp>
+        <p:nvSpPr>
+          <p:cNvPr id="7" name="TextBox 6"/>
+          <p:cNvSpPr txBox="1"/>
+          <p:nvPr/>
+        </p:nvSpPr>
+        <p:spPr>
+          <a:xfrm>
+            <a:off x="822959" y="1847088"/>
+            <a:ext cx="640080" cy="457200"/>
+          </a:xfrm>
+          <a:prstGeom prst="rect">
+            <a:avLst/>
+          </a:prstGeom>
+          <a:noFill/>
+        </p:spPr>
+        <p:txBody>
+          <a:bodyPr wrap="square" anchor="t" lIns="0" rIns="0" tIns="0" bIns="0">
+            <a:spAutoFit/>
+          </a:bodyPr>
+          <a:lstStyle/>
+          <a:p>
+            <a:pPr algn="l">
+              <a:lnSpc>
+                <a:spcPct val="105000"/>
+              </a:lnSpc>
+            </a:pPr>
+            <a:r>
+              <a:rPr sz="1900" b="1">
+                <a:solidFill>
+                  <a:srgbClr val="25C6D2"/>
+                </a:solidFill>
+                <a:latin typeface="Consolas"/>
+              </a:rPr>
+              <a:t>01</a:t>
+            </a:r>
+          </a:p>
+        </p:txBody>
+      </p:sp>
+      <p:sp>
+        <p:nvSpPr>
+          <p:cNvPr id="8" name="TextBox 7"/>
+          <p:cNvSpPr txBox="1"/>
+          <p:nvPr/>
+        </p:nvSpPr>
+        <p:spPr>
+          <a:xfrm>
+            <a:off x="1508760" y="1865376"/>
+            <a:ext cx="4251960" cy="548640"/>
+          </a:xfrm>
+          <a:prstGeom prst="rect">
+            <a:avLst/>
+          </a:prstGeom>
+          <a:noFill/>
+        </p:spPr>
+        <p:txBody>
+          <a:bodyPr wrap="square" anchor="t" lIns="0" rIns="0" tIns="0" bIns="0">
+            <a:spAutoFit/>
+          </a:bodyPr>
+          <a:lstStyle/>
+          <a:p>
+            <a:pPr algn="l">
+              <a:lnSpc>
+                <a:spcPct val="100000"/>
+              </a:lnSpc>
+            </a:pPr>
+            <a:r>
+              <a:rPr sz="1400" b="1">
+                <a:solidFill>
+                  <a:srgbClr val="E7ECF2"/>
+                </a:solidFill>
+                <a:latin typeface="Arial"/>
+              </a:rPr>
+              <a:t>Analog state buys energy, not quality</a:t>
+            </a:r>
+          </a:p>
+        </p:txBody>
+      </p:sp>
+      <p:sp>
+        <p:nvSpPr>
+          <p:cNvPr id="9" name="TextBox 8"/>
+          <p:cNvSpPr txBox="1"/>
+          <p:nvPr/>
+        </p:nvSpPr>
+        <p:spPr>
+          <a:xfrm>
+            <a:off x="1508760" y="2395728"/>
+            <a:ext cx="4297680" cy="914400"/>
+          </a:xfrm>
+          <a:prstGeom prst="rect">
+            <a:avLst/>
+          </a:prstGeom>
+          <a:noFill/>
+        </p:spPr>
+        <p:txBody>
+          <a:bodyPr wrap="square" anchor="t" lIns="0" rIns="0" tIns="0" bIns="0">
+            <a:spAutoFit/>
+          </a:bodyPr>
+          <a:lstStyle/>
+          <a:p>
+            <a:pPr algn="l">
+              <a:lnSpc>
+                <a:spcPct val="118000"/>
+              </a:lnSpc>
+            </a:pPr>
+            <a:r>
+              <a:rPr sz="1130" b="0">
+                <a:solidFill>
+                  <a:srgbClr val="93A0AE"/>
+                </a:solidFill>
+                <a:latin typeface="Arial"/>
+              </a:rPr>
+              <a:t>Param-matched 4-way SSM, char-LM, 3 seeds: analog state cuts proxy energy 1.60× (446k vs 712k pJ/token) for +0.160 bpc. “Beats digital” is retracted — the same noise on the digital baseline is worth −0.309 bpc.</a:t>
+            </a:r>
+          </a:p>
+        </p:txBody>
+      </p:sp>
+      <p:sp>
+        <p:nvSpPr>
+          <p:cNvPr id="10" name="Rounded Rectangle 9"/>
+          <p:cNvSpPr/>
+          <p:nvPr/>
+        </p:nvSpPr>
+        <p:spPr>
+          <a:xfrm>
+            <a:off x="6263640" y="1645920"/>
+            <a:ext cx="5440680" cy="1691640"/>
+          </a:xfrm>
+          <a:prstGeom prst="roundRect">
+            <a:avLst>
+              <a:gd name="adj" fmla="val 8000"/>
+            </a:avLst>
+          </a:prstGeom>
+          <a:solidFill>
+            <a:srgbClr val="161C24"/>
+          </a:solidFill>
+          <a:ln w="12700">
+            <a:solidFill>
+              <a:srgbClr val="2A3440"/>
+            </a:solidFill>
+          </a:ln>
+          <a:effectLst/>
+        </p:spPr>
+        <p:style>
+          <a:lnRef idx="1">
+            <a:schemeClr val="accent1"/>
+          </a:lnRef>
+          <a:fillRef idx="3">
+            <a:schemeClr val="accent1"/>
+          </a:fillRef>
+          <a:effectRef idx="2">
+            <a:schemeClr val="accent1"/>
+          </a:effectRef>
+          <a:fontRef idx="minor">
+            <a:schemeClr val="lt1"/>
+          </a:fontRef>
+        </p:style>
+        <p:txBody>
+          <a:bodyPr rtlCol="0" anchor="ctr"/>
+          <a:lstStyle/>
+          <a:p>
+            <a:pPr algn="ctr"/>
+          </a:p>
+        </p:txBody>
+      </p:sp>
+      <p:sp>
+        <p:nvSpPr>
+          <p:cNvPr id="11" name="TextBox 10"/>
+          <p:cNvSpPr txBox="1"/>
+          <p:nvPr/>
+        </p:nvSpPr>
+        <p:spPr>
+          <a:xfrm>
+            <a:off x="6537959" y="1847088"/>
+            <a:ext cx="640080" cy="457200"/>
+          </a:xfrm>
+          <a:prstGeom prst="rect">
+            <a:avLst/>
+          </a:prstGeom>
+          <a:noFill/>
+        </p:spPr>
+        <p:txBody>
+          <a:bodyPr wrap="square" anchor="t" lIns="0" rIns="0" tIns="0" bIns="0">
+            <a:spAutoFit/>
+          </a:bodyPr>
+          <a:lstStyle/>
+          <a:p>
+            <a:pPr algn="l">
+              <a:lnSpc>
+                <a:spcPct val="105000"/>
+              </a:lnSpc>
+            </a:pPr>
+            <a:r>
+              <a:rPr sz="1900" b="1">
+                <a:solidFill>
+                  <a:srgbClr val="25C6D2"/>
+                </a:solidFill>
+                <a:latin typeface="Consolas"/>
+              </a:rPr>
+              <a:t>02</a:t>
+            </a:r>
+          </a:p>
+        </p:txBody>
+      </p:sp>
+      <p:sp>
+        <p:nvSpPr>
+          <p:cNvPr id="12" name="TextBox 11"/>
+          <p:cNvSpPr txBox="1"/>
+          <p:nvPr/>
+        </p:nvSpPr>
+        <p:spPr>
+          <a:xfrm>
+            <a:off x="7223759" y="1865376"/>
+            <a:ext cx="4251960" cy="548640"/>
+          </a:xfrm>
+          <a:prstGeom prst="rect">
+            <a:avLst/>
+          </a:prstGeom>
+          <a:noFill/>
+        </p:spPr>
+        <p:txBody>
+          <a:bodyPr wrap="square" anchor="t" lIns="0" rIns="0" tIns="0" bIns="0">
+            <a:spAutoFit/>
+          </a:bodyPr>
+          <a:lstStyle/>
+          <a:p>
+            <a:pPr algn="l">
+              <a:lnSpc>
+                <a:spcPct val="100000"/>
+              </a:lnSpc>
+            </a:pPr>
+            <a:r>
+              <a:rPr sz="1400" b="1">
+                <a:solidFill>
+                  <a:srgbClr val="E7ECF2"/>
+                </a:solidFill>
+                <a:latin typeface="Arial"/>
+              </a:rPr>
+              <a:t>The variant ranking inverts by workload</a:t>
+            </a:r>
+          </a:p>
+        </p:txBody>
+      </p:sp>
+      <p:sp>
+        <p:nvSpPr>
+          <p:cNvPr id="13" name="TextBox 12"/>
+          <p:cNvSpPr txBox="1"/>
+          <p:nvPr/>
+        </p:nvSpPr>
+        <p:spPr>
+          <a:xfrm>
+            <a:off x="7223759" y="2395728"/>
+            <a:ext cx="4297680" cy="914400"/>
+          </a:xfrm>
+          <a:prstGeom prst="rect">
+            <a:avLst/>
+          </a:prstGeom>
+          <a:noFill/>
+        </p:spPr>
+        <p:txBody>
+          <a:bodyPr wrap="square" anchor="t" lIns="0" rIns="0" tIns="0" bIns="0">
+            <a:spAutoFit/>
+          </a:bodyPr>
+          <a:lstStyle/>
+          <a:p>
+            <a:pPr algn="l">
+              <a:lnSpc>
+                <a:spcPct val="118000"/>
+              </a:lnSpc>
+            </a:pPr>
+            <a:r>
+              <a:rPr sz="1130" b="0">
+                <a:solidFill>
+                  <a:srgbClr val="93A0AE"/>
+                </a:solidFill>
+                <a:latin typeface="Arial"/>
+              </a:rPr>
+              <a:t>At matched communication rate the order inverts: char-LM analog ≪ spiking-state ≪ output-spiking; precise recall (copy) the reverse — margin kept 0.87 / 0.50 / 0.074. A 1-bit state is at exactly chance, and cheapest.</a:t>
+            </a:r>
+          </a:p>
+        </p:txBody>
+      </p:sp>
+      <p:sp>
+        <p:nvSpPr>
+          <p:cNvPr id="14" name="Rounded Rectangle 13"/>
+          <p:cNvSpPr/>
+          <p:nvPr/>
+        </p:nvSpPr>
+        <p:spPr>
+          <a:xfrm>
+            <a:off x="548640" y="3520439"/>
+            <a:ext cx="5440680" cy="1691640"/>
+          </a:xfrm>
+          <a:prstGeom prst="roundRect">
+            <a:avLst>
+              <a:gd name="adj" fmla="val 8000"/>
+            </a:avLst>
+          </a:prstGeom>
+          <a:solidFill>
+            <a:srgbClr val="161C24"/>
+          </a:solidFill>
+          <a:ln w="12700">
+            <a:solidFill>
+              <a:srgbClr val="2A3440"/>
+            </a:solidFill>
+          </a:ln>
+          <a:effectLst/>
+        </p:spPr>
+        <p:style>
+          <a:lnRef idx="1">
+            <a:schemeClr val="accent1"/>
+          </a:lnRef>
+          <a:fillRef idx="3">
+            <a:schemeClr val="accent1"/>
+          </a:fillRef>
+          <a:effectRef idx="2">
+            <a:schemeClr val="accent1"/>
+          </a:effectRef>
+          <a:fontRef idx="minor">
+            <a:schemeClr val="lt1"/>
+          </a:fontRef>
+        </p:style>
+        <p:txBody>
+          <a:bodyPr rtlCol="0" anchor="ctr"/>
+          <a:lstStyle/>
+          <a:p>
+            <a:pPr algn="ctr"/>
+          </a:p>
+        </p:txBody>
+      </p:sp>
+      <p:sp>
+        <p:nvSpPr>
+          <p:cNvPr id="15" name="TextBox 14"/>
+          <p:cNvSpPr txBox="1"/>
+          <p:nvPr/>
+        </p:nvSpPr>
+        <p:spPr>
+          <a:xfrm>
+            <a:off x="822959" y="3721607"/>
+            <a:ext cx="640080" cy="457200"/>
+          </a:xfrm>
+          <a:prstGeom prst="rect">
+            <a:avLst/>
+          </a:prstGeom>
+          <a:noFill/>
+        </p:spPr>
+        <p:txBody>
+          <a:bodyPr wrap="square" anchor="t" lIns="0" rIns="0" tIns="0" bIns="0">
+            <a:spAutoFit/>
+          </a:bodyPr>
+          <a:lstStyle/>
+          <a:p>
+            <a:pPr algn="l">
+              <a:lnSpc>
+                <a:spcPct val="105000"/>
+              </a:lnSpc>
+            </a:pPr>
+            <a:r>
+              <a:rPr sz="1900" b="1">
+                <a:solidFill>
+                  <a:srgbClr val="25C6D2"/>
+                </a:solidFill>
+                <a:latin typeface="Consolas"/>
+              </a:rPr>
+              <a:t>03</a:t>
+            </a:r>
+          </a:p>
+        </p:txBody>
+      </p:sp>
+      <p:sp>
+        <p:nvSpPr>
+          <p:cNvPr id="16" name="TextBox 15"/>
+          <p:cNvSpPr txBox="1"/>
+          <p:nvPr/>
+        </p:nvSpPr>
+        <p:spPr>
+          <a:xfrm>
+            <a:off x="1508760" y="3739896"/>
+            <a:ext cx="4251960" cy="548640"/>
+          </a:xfrm>
+          <a:prstGeom prst="rect">
+            <a:avLst/>
+          </a:prstGeom>
+          <a:noFill/>
+        </p:spPr>
+        <p:txBody>
+          <a:bodyPr wrap="square" anchor="t" lIns="0" rIns="0" tIns="0" bIns="0">
+            <a:spAutoFit/>
+          </a:bodyPr>
+          <a:lstStyle/>
+          <a:p>
+            <a:pPr algn="l">
+              <a:lnSpc>
+                <a:spcPct val="100000"/>
+              </a:lnSpc>
+            </a:pPr>
+            <a:r>
+              <a:rPr sz="1400" b="1">
+                <a:solidFill>
+                  <a:srgbClr val="E7ECF2"/>
+                </a:solidFill>
+                <a:latin typeface="Arial"/>
+              </a:rPr>
+              <a:t>Degrade what the task ignores</a:t>
+            </a:r>
+          </a:p>
+        </p:txBody>
+      </p:sp>
+      <p:sp>
+        <p:nvSpPr>
+          <p:cNvPr id="17" name="TextBox 16"/>
+          <p:cNvSpPr txBox="1"/>
+          <p:nvPr/>
+        </p:nvSpPr>
+        <p:spPr>
+          <a:xfrm>
+            <a:off x="1508760" y="4270248"/>
+            <a:ext cx="4297680" cy="914400"/>
+          </a:xfrm>
+          <a:prstGeom prst="rect">
+            <a:avLst/>
+          </a:prstGeom>
+          <a:noFill/>
+        </p:spPr>
+        <p:txBody>
+          <a:bodyPr wrap="square" anchor="t" lIns="0" rIns="0" tIns="0" bIns="0">
+            <a:spAutoFit/>
+          </a:bodyPr>
+          <a:lstStyle/>
+          <a:p>
+            <a:pPr algn="l">
+              <a:lnSpc>
+                <a:spcPct val="118000"/>
+              </a:lnSpc>
+            </a:pPr>
+            <a:r>
+              <a:rPr sz="1130" b="0">
+                <a:solidFill>
+                  <a:srgbClr val="93A0AE"/>
+                </a:solidFill>
+                <a:latin typeface="Arial"/>
+              </a:rPr>
+              <a:t>One principle covers both: a degradation is cheap only where the loss does not depend on it. The same 6-bit state quantizer costs −0.002 bpc on char-LM and +0.37 on copy (post-hoc, not pre-registered).</a:t>
+            </a:r>
+          </a:p>
+        </p:txBody>
+      </p:sp>
+      <p:sp>
+        <p:nvSpPr>
+          <p:cNvPr id="18" name="Rounded Rectangle 17"/>
+          <p:cNvSpPr/>
+          <p:nvPr/>
+        </p:nvSpPr>
+        <p:spPr>
+          <a:xfrm>
+            <a:off x="6263640" y="3520439"/>
+            <a:ext cx="5440680" cy="1691640"/>
+          </a:xfrm>
+          <a:prstGeom prst="roundRect">
+            <a:avLst>
+              <a:gd name="adj" fmla="val 8000"/>
+            </a:avLst>
+          </a:prstGeom>
+          <a:solidFill>
+            <a:srgbClr val="161C24"/>
+          </a:solidFill>
+          <a:ln w="12700">
+            <a:solidFill>
+              <a:srgbClr val="2A3440"/>
+            </a:solidFill>
+          </a:ln>
+          <a:effectLst/>
+        </p:spPr>
+        <p:style>
+          <a:lnRef idx="1">
+            <a:schemeClr val="accent1"/>
+          </a:lnRef>
+          <a:fillRef idx="3">
+            <a:schemeClr val="accent1"/>
+          </a:fillRef>
+          <a:effectRef idx="2">
+            <a:schemeClr val="accent1"/>
+          </a:effectRef>
+          <a:fontRef idx="minor">
+            <a:schemeClr val="lt1"/>
+          </a:fontRef>
+        </p:style>
+        <p:txBody>
+          <a:bodyPr rtlCol="0" anchor="ctr"/>
+          <a:lstStyle/>
+          <a:p>
+            <a:pPr algn="ctr"/>
+          </a:p>
+        </p:txBody>
+      </p:sp>
+      <p:sp>
+        <p:nvSpPr>
+          <p:cNvPr id="19" name="TextBox 18"/>
+          <p:cNvSpPr txBox="1"/>
+          <p:nvPr/>
+        </p:nvSpPr>
+        <p:spPr>
+          <a:xfrm>
+            <a:off x="6537959" y="3721607"/>
+            <a:ext cx="640080" cy="457200"/>
+          </a:xfrm>
+          <a:prstGeom prst="rect">
+            <a:avLst/>
+          </a:prstGeom>
+          <a:noFill/>
+        </p:spPr>
+        <p:txBody>
+          <a:bodyPr wrap="square" anchor="t" lIns="0" rIns="0" tIns="0" bIns="0">
+            <a:spAutoFit/>
+          </a:bodyPr>
+          <a:lstStyle/>
+          <a:p>
+            <a:pPr algn="l">
+              <a:lnSpc>
+                <a:spcPct val="105000"/>
+              </a:lnSpc>
+            </a:pPr>
+            <a:r>
+              <a:rPr sz="1900" b="1">
+                <a:solidFill>
+                  <a:srgbClr val="25C6D2"/>
+                </a:solidFill>
+                <a:latin typeface="Consolas"/>
+              </a:rPr>
+              <a:t>04</a:t>
+            </a:r>
+          </a:p>
+        </p:txBody>
+      </p:sp>
+      <p:sp>
+        <p:nvSpPr>
+          <p:cNvPr id="20" name="TextBox 19"/>
+          <p:cNvSpPr txBox="1"/>
+          <p:nvPr/>
+        </p:nvSpPr>
+        <p:spPr>
+          <a:xfrm>
+            <a:off x="7223759" y="3739896"/>
+            <a:ext cx="4251960" cy="548640"/>
+          </a:xfrm>
+          <a:prstGeom prst="rect">
+            <a:avLst/>
+          </a:prstGeom>
+          <a:noFill/>
+        </p:spPr>
+        <p:txBody>
+          <a:bodyPr wrap="square" anchor="t" lIns="0" rIns="0" tIns="0" bIns="0">
+            <a:spAutoFit/>
+          </a:bodyPr>
+          <a:lstStyle/>
+          <a:p>
+            <a:pPr algn="l">
+              <a:lnSpc>
+                <a:spcPct val="100000"/>
+              </a:lnSpc>
+            </a:pPr>
+            <a:r>
+              <a:rPr sz="1400" b="1">
+                <a:solidFill>
+                  <a:srgbClr val="E7ECF2"/>
+                </a:solidFill>
+                <a:latin typeface="Arial"/>
+              </a:rPr>
+              <a:t>My own bound did not survive its test</a:t>
+            </a:r>
+          </a:p>
+        </p:txBody>
+      </p:sp>
+      <p:sp>
+        <p:nvSpPr>
+          <p:cNvPr id="21" name="TextBox 20"/>
+          <p:cNvSpPr txBox="1"/>
+          <p:nvPr/>
+        </p:nvSpPr>
+        <p:spPr>
+          <a:xfrm>
+            <a:off x="7223759" y="4270248"/>
+            <a:ext cx="4297680" cy="914400"/>
+          </a:xfrm>
+          <a:prstGeom prst="rect">
+            <a:avLst/>
+          </a:prstGeom>
+          <a:noFill/>
+        </p:spPr>
+        <p:txBody>
+          <a:bodyPr wrap="square" anchor="t" lIns="0" rIns="0" tIns="0" bIns="0">
+            <a:spAutoFit/>
+          </a:bodyPr>
+          <a:lstStyle/>
+          <a:p>
+            <a:pPr algn="l">
+              <a:lnSpc>
+                <a:spcPct val="118000"/>
+              </a:lnSpc>
+            </a:pPr>
+            <a:r>
+              <a:rPr sz="1130" b="0">
+                <a:solidFill>
+                  <a:srgbClr val="93A0AE"/>
+                </a:solidFill>
+                <a:latin typeface="Arial"/>
+              </a:rPr>
+              <a:t>Shrink-H, 3 seeds per width: the predicted floor rises 12× while measured state activity falls 0.496→0.250, and accuracy improves as capacity shrinks. Theory with a tested scope limit, not a validated prediction.</a:t>
+            </a:r>
+          </a:p>
+        </p:txBody>
+      </p:sp>
+    </p:spTree>
+  </p:cSld>
+  <p:clrMapOvr>
+    <a:masterClrMapping/>
+  </p:clrMapOvr>
+</p:sld>
+</file>
+
 <file path=ppt/slides/slide2.xml><?xml version="1.0" encoding="utf-8"?>
 <p:sld xmlns:a="http://schemas.openxmlformats.org/drawingml/2006/main" xmlns:p="http://schemas.openxmlformats.org/presentationml/2006/main" xmlns:r="http://schemas.openxmlformats.org/officeDocument/2006/relationships">
   <p:cSld>
@@ -9902,7 +10745,7 @@
                 </a:solidFill>
                 <a:latin typeface="Arial"/>
               </a:rPr>
-              <a:t>memory in membranes/synapses, not a KV cache → no memory wall, no firing floor</a:t>
+              <a:t>memory in membranes/synapses, not a KV cache → no memory wall; the firing floor is a spiking-state property (the bound itself: theory, scope limit tested)</a:t>
             </a:r>
           </a:p>
         </p:txBody>
@@ -10867,7 +11710,7 @@
                 </a:solidFill>
                 <a:latin typeface="Consolas"/>
               </a:rPr>
-              <a:t>07 · PROPOSED DIRECTIONS</a:t>
+              <a:t>08 · PROPOSED DIRECTIONS</a:t>
             </a:r>
           </a:p>
         </p:txBody>
@@ -10945,7 +11788,7 @@
                 </a:solidFill>
                 <a:latin typeface="Consolas"/>
               </a:rPr>
-              <a:t>08</a:t>
+              <a:t>09</a:t>
             </a:r>
           </a:p>
         </p:txBody>
@@ -10984,7 +11827,7 @@
                 </a:solidFill>
                 <a:latin typeface="Arial"/>
               </a:rPr>
-              <a:t>What I would work on</a:t>
+              <a:t>What I would work on next</a:t>
             </a:r>
           </a:p>
         </p:txBody>
@@ -11110,7 +11953,7 @@
                 </a:solidFill>
                 <a:latin typeface="Arial"/>
               </a:rPr>
-              <a:t>Escape the firing floor with analog state</a:t>
+              <a:t>Analog state — done in simulation, open in silicon</a:t>
             </a:r>
           </a:p>
         </p:txBody>
@@ -11149,7 +11992,7 @@
                 </a:solidFill>
                 <a:latin typeface="Arial"/>
               </a:rPr>
-              <a:t>Build an SSM whose recurrent state lives in sub-threshold analog dynamics, not spikes — test whether it breaks our bound's assumption and sparsifies like attention did.</a:t>
+              <a:t>Finished in simulation (two tasks, three seeds); what is unfinished is physical — every pJ figure is a 45nm proxy and the analog storage element and converter are unpriced. So 02 first, not more simulation.</a:t>
             </a:r>
           </a:p>
         </p:txBody>

</xml_diff>

<commit_message>
talk deck: add the stranded-readout / energy-datapath result (block 05) and de-stale the converters line
patch_deck2.py adds a full-width band to the SSM RESULTS slide (readout 75% of
analog pJ/token vs recurrence 8%, 1.74x free-recurrence ceiling, event readout
costs ~+1.0 bpc char-LM and all of copy margin at 3 seeds, converters priced
0.00-0.33%) and replaces the directions slide claim that converters are
unpriced. Numbers copied from the published ledger entries, none re-derived.
Layout verified by rasterizing the built PDF; first attempt overlapped rows
03/04 and was redone as a slim band.

Co-Authored-By: Claude Fable 5 <noreply@anthropic.com>
</commit_message>
<xml_diff>
--- a/talk/beyond_attention_paradigms.pptx
+++ b/talk/beyond_attention_paradigms.pptx
@@ -4632,183 +4632,23 @@
       <p:grpSpPr/>
       <p:sp>
         <p:nvSpPr>
-          <p:cNvPr id="2" name="TextBox 1"/>
-          <p:cNvSpPr txBox="1"/>
-          <p:nvPr/>
-        </p:nvSpPr>
-        <p:spPr>
-          <a:xfrm>
-            <a:off x="548640" y="457200"/>
-            <a:ext cx="10972800" cy="274320"/>
-          </a:xfrm>
-          <a:prstGeom prst="rect">
-            <a:avLst/>
-          </a:prstGeom>
-          <a:noFill/>
-        </p:spPr>
-        <p:txBody>
-          <a:bodyPr wrap="square" anchor="t" lIns="0" rIns="0" tIns="0" bIns="0">
-            <a:spAutoFit/>
-          </a:bodyPr>
-          <a:lstStyle/>
-          <a:p>
-            <a:pPr algn="l">
-              <a:lnSpc>
-                <a:spcPct val="105000"/>
-              </a:lnSpc>
-            </a:pPr>
-            <a:r>
-              <a:rPr sz="1150" b="1" spc="140">
-                <a:solidFill>
-                  <a:srgbClr val="25C6D2"/>
-                </a:solidFill>
-                <a:latin typeface="Consolas"/>
-              </a:rPr>
-              <a:t>07 · SSM RESULTS</a:t>
-            </a:r>
-          </a:p>
-        </p:txBody>
-      </p:sp>
-      <p:sp>
-        <p:nvSpPr>
-          <p:cNvPr id="3" name="TextBox 2"/>
-          <p:cNvSpPr txBox="1"/>
-          <p:nvPr/>
-        </p:nvSpPr>
-        <p:spPr>
-          <a:xfrm>
-            <a:off x="548640" y="6400800"/>
-            <a:ext cx="8229600" cy="274320"/>
-          </a:xfrm>
-          <a:prstGeom prst="rect">
-            <a:avLst/>
-          </a:prstGeom>
-          <a:noFill/>
-        </p:spPr>
-        <p:txBody>
-          <a:bodyPr wrap="square" anchor="t" lIns="0" rIns="0" tIns="0" bIns="0">
-            <a:spAutoFit/>
-          </a:bodyPr>
-          <a:lstStyle/>
-          <a:p>
-            <a:pPr algn="l">
-              <a:lnSpc>
-                <a:spcPct val="105000"/>
-              </a:lnSpc>
-            </a:pPr>
-            <a:r>
-              <a:rPr sz="850" b="0" spc="110">
-                <a:solidFill>
-                  <a:srgbClr val="667280"/>
-                </a:solidFill>
-                <a:latin typeface="Consolas"/>
-              </a:rPr>
-              <a:t>BEYOND ATTENTION · NEUROMORPHIC INTELLIGENCE PARADIGMS</a:t>
-            </a:r>
-          </a:p>
-        </p:txBody>
-      </p:sp>
-      <p:sp>
-        <p:nvSpPr>
-          <p:cNvPr id="4" name="TextBox 3"/>
-          <p:cNvSpPr txBox="1"/>
-          <p:nvPr/>
-        </p:nvSpPr>
-        <p:spPr>
-          <a:xfrm>
-            <a:off x="10911535" y="6400800"/>
-            <a:ext cx="731520" cy="274320"/>
-          </a:xfrm>
-          <a:prstGeom prst="rect">
-            <a:avLst/>
-          </a:prstGeom>
-          <a:noFill/>
-        </p:spPr>
-        <p:txBody>
-          <a:bodyPr wrap="square" anchor="t" lIns="0" rIns="0" tIns="0" bIns="0">
-            <a:spAutoFit/>
-          </a:bodyPr>
-          <a:lstStyle/>
-          <a:p>
-            <a:pPr algn="r">
-              <a:lnSpc>
-                <a:spcPct val="105000"/>
-              </a:lnSpc>
-            </a:pPr>
-            <a:r>
-              <a:rPr sz="850" b="0">
-                <a:solidFill>
-                  <a:srgbClr val="667280"/>
-                </a:solidFill>
-                <a:latin typeface="Consolas"/>
-              </a:rPr>
-              <a:t>08</a:t>
-            </a:r>
-          </a:p>
-        </p:txBody>
-      </p:sp>
-      <p:sp>
-        <p:nvSpPr>
-          <p:cNvPr id="5" name="TextBox 4"/>
-          <p:cNvSpPr txBox="1"/>
-          <p:nvPr/>
-        </p:nvSpPr>
-        <p:spPr>
-          <a:xfrm>
-            <a:off x="548640" y="822960"/>
-            <a:ext cx="10972800" cy="548640"/>
-          </a:xfrm>
-          <a:prstGeom prst="rect">
-            <a:avLst/>
-          </a:prstGeom>
-          <a:noFill/>
-        </p:spPr>
-        <p:txBody>
-          <a:bodyPr wrap="square" anchor="t" lIns="0" rIns="0" tIns="0" bIns="0">
-            <a:spAutoFit/>
-          </a:bodyPr>
-          <a:lstStyle/>
-          <a:p>
-            <a:pPr algn="l">
-              <a:lnSpc>
-                <a:spcPct val="105000"/>
-              </a:lnSpc>
-            </a:pPr>
-            <a:r>
-              <a:rPr sz="2400" b="1">
-                <a:solidFill>
-                  <a:srgbClr val="E7ECF2"/>
-                </a:solidFill>
-                <a:latin typeface="Arial"/>
-              </a:rPr>
-              <a:t>Direction One, run: what the analog-state SSM actually did</a:t>
-            </a:r>
-          </a:p>
-        </p:txBody>
-      </p:sp>
-      <p:sp>
-        <p:nvSpPr>
-          <p:cNvPr id="6" name="Rounded Rectangle 5"/>
+          <p:cNvPr id="2" name="Rectangle 1"/>
           <p:cNvSpPr/>
           <p:nvPr/>
         </p:nvSpPr>
         <p:spPr>
           <a:xfrm>
-            <a:off x="548640" y="1645920"/>
-            <a:ext cx="5440680" cy="1691640"/>
-          </a:xfrm>
-          <a:prstGeom prst="roundRect">
-            <a:avLst>
-              <a:gd name="adj" fmla="val 8000"/>
-            </a:avLst>
+            <a:off x="0" y="0"/>
+            <a:ext cx="146304" cy="6858000"/>
+          </a:xfrm>
+          <a:prstGeom prst="rect">
+            <a:avLst/>
           </a:prstGeom>
           <a:solidFill>
-            <a:srgbClr val="161C24"/>
+            <a:srgbClr val="9B8CFF"/>
           </a:solidFill>
-          <a:ln w="12700">
-            <a:solidFill>
-              <a:srgbClr val="2A3440"/>
-            </a:solidFill>
+          <a:ln>
+            <a:noFill/>
           </a:ln>
           <a:effectLst/>
         </p:spPr>
@@ -4836,14 +4676,14 @@
       </p:sp>
       <p:sp>
         <p:nvSpPr>
-          <p:cNvPr id="7" name="TextBox 6"/>
-          <p:cNvSpPr txBox="1"/>
-          <p:nvPr/>
-        </p:nvSpPr>
-        <p:spPr>
-          <a:xfrm>
-            <a:off x="822959" y="1847088"/>
-            <a:ext cx="640080" cy="457200"/>
+          <p:cNvPr id="3" name="TextBox 2"/>
+          <p:cNvSpPr txBox="1"/>
+          <p:nvPr/>
+        </p:nvSpPr>
+        <p:spPr>
+          <a:xfrm>
+            <a:off x="822960" y="1371600"/>
+            <a:ext cx="10972800" cy="274320"/>
           </a:xfrm>
           <a:prstGeom prst="rect">
             <a:avLst/>
@@ -4862,27 +4702,27 @@
               </a:lnSpc>
             </a:pPr>
             <a:r>
-              <a:rPr sz="1900" b="1">
-                <a:solidFill>
-                  <a:srgbClr val="25C6D2"/>
+              <a:rPr sz="1150" b="1" spc="140">
+                <a:solidFill>
+                  <a:srgbClr val="9B8CFF"/>
                 </a:solidFill>
                 <a:latin typeface="Consolas"/>
               </a:rPr>
-              <a:t>01</a:t>
-            </a:r>
-          </a:p>
-        </p:txBody>
-      </p:sp>
-      <p:sp>
-        <p:nvSpPr>
-          <p:cNvPr id="8" name="TextBox 7"/>
-          <p:cNvSpPr txBox="1"/>
-          <p:nvPr/>
-        </p:nvSpPr>
-        <p:spPr>
-          <a:xfrm>
-            <a:off x="1508760" y="1865376"/>
-            <a:ext cx="4251960" cy="548640"/>
+              <a:t>THESIS</a:t>
+            </a:r>
+          </a:p>
+        </p:txBody>
+      </p:sp>
+      <p:sp>
+        <p:nvSpPr>
+          <p:cNvPr id="4" name="TextBox 3"/>
+          <p:cNvSpPr txBox="1"/>
+          <p:nvPr/>
+        </p:nvSpPr>
+        <p:spPr>
+          <a:xfrm>
+            <a:off x="786384" y="1828800"/>
+            <a:ext cx="10424160" cy="2377440"/>
           </a:xfrm>
           <a:prstGeom prst="rect">
             <a:avLst/>
@@ -4897,31 +4737,59 @@
           <a:p>
             <a:pPr algn="l">
               <a:lnSpc>
-                <a:spcPct val="100000"/>
-              </a:lnSpc>
-            </a:pPr>
-            <a:r>
-              <a:rPr sz="1400" b="1">
+                <a:spcPct val="110000"/>
+              </a:lnSpc>
+            </a:pPr>
+            <a:r>
+              <a:rPr sz="3000" b="1">
                 <a:solidFill>
                   <a:srgbClr val="E7ECF2"/>
                 </a:solidFill>
                 <a:latin typeface="Arial"/>
               </a:rPr>
-              <a:t>Analog state buys energy, not quality</a:t>
-            </a:r>
-          </a:p>
-        </p:txBody>
-      </p:sp>
-      <p:sp>
-        <p:nvSpPr>
-          <p:cNvPr id="9" name="TextBox 8"/>
-          <p:cNvSpPr txBox="1"/>
-          <p:nvPr/>
-        </p:nvSpPr>
-        <p:spPr>
-          <a:xfrm>
-            <a:off x="1508760" y="2395728"/>
-            <a:ext cx="4297680" cy="914400"/>
+              <a:t>Intelligence is a loop, not a lookup.
+</a:t>
+            </a:r>
+            <a:r>
+              <a:rPr sz="2000" b="1">
+                <a:solidFill>
+                  <a:srgbClr val="93A0AE"/>
+                </a:solidFill>
+                <a:latin typeface="Arial"/>
+              </a:rPr>
+              <a:t>If neuromorphic can't ride attention, it shouldn't — its physics aligns with the </a:t>
+            </a:r>
+            <a:r>
+              <a:rPr sz="2000" b="1">
+                <a:solidFill>
+                  <a:srgbClr val="9B8CFF"/>
+                </a:solidFill>
+                <a:latin typeface="Arial"/>
+              </a:rPr>
+              <a:t>predictive, sparse, local, embodied</a:t>
+            </a:r>
+            <a:r>
+              <a:rPr sz="2000" b="1">
+                <a:solidFill>
+                  <a:srgbClr val="93A0AE"/>
+                </a:solidFill>
+                <a:latin typeface="Arial"/>
+              </a:rPr>
+              <a:t> paradigm the brain already proves works at 20 W.</a:t>
+            </a:r>
+          </a:p>
+        </p:txBody>
+      </p:sp>
+      <p:sp>
+        <p:nvSpPr>
+          <p:cNvPr id="5" name="TextBox 4"/>
+          <p:cNvSpPr txBox="1"/>
+          <p:nvPr/>
+        </p:nvSpPr>
+        <p:spPr>
+          <a:xfrm>
+            <a:off x="822960" y="4937760"/>
+            <a:ext cx="10515600" cy="1097280"/>
           </a:xfrm>
           <a:prstGeom prst="rect">
             <a:avLst/>
@@ -4936,512 +4804,26 @@
           <a:p>
             <a:pPr algn="l">
               <a:lnSpc>
-                <a:spcPct val="118000"/>
-              </a:lnSpc>
-            </a:pPr>
-            <a:r>
-              <a:rPr sz="1130" b="0">
-                <a:solidFill>
-                  <a:srgbClr val="93A0AE"/>
-                </a:solidFill>
-                <a:latin typeface="Arial"/>
-              </a:rPr>
-              <a:t>Param-matched 4-way SSM, char-LM, 3 seeds: analog state cuts proxy energy 1.60× (446k vs 712k pJ/token) for +0.160 bpc. “Beats digital” is retracted — the same noise on the digital baseline is worth −0.309 bpc.</a:t>
-            </a:r>
-          </a:p>
-        </p:txBody>
-      </p:sp>
-      <p:sp>
-        <p:nvSpPr>
-          <p:cNvPr id="10" name="Rounded Rectangle 9"/>
-          <p:cNvSpPr/>
-          <p:nvPr/>
-        </p:nvSpPr>
-        <p:spPr>
-          <a:xfrm>
-            <a:off x="6263640" y="1645920"/>
-            <a:ext cx="5440680" cy="1691640"/>
-          </a:xfrm>
-          <a:prstGeom prst="roundRect">
-            <a:avLst>
-              <a:gd name="adj" fmla="val 8000"/>
-            </a:avLst>
-          </a:prstGeom>
-          <a:solidFill>
-            <a:srgbClr val="161C24"/>
-          </a:solidFill>
-          <a:ln w="12700">
-            <a:solidFill>
-              <a:srgbClr val="2A3440"/>
-            </a:solidFill>
-          </a:ln>
-          <a:effectLst/>
-        </p:spPr>
-        <p:style>
-          <a:lnRef idx="1">
-            <a:schemeClr val="accent1"/>
-          </a:lnRef>
-          <a:fillRef idx="3">
-            <a:schemeClr val="accent1"/>
-          </a:fillRef>
-          <a:effectRef idx="2">
-            <a:schemeClr val="accent1"/>
-          </a:effectRef>
-          <a:fontRef idx="minor">
-            <a:schemeClr val="lt1"/>
-          </a:fontRef>
-        </p:style>
-        <p:txBody>
-          <a:bodyPr rtlCol="0" anchor="ctr"/>
-          <a:lstStyle/>
-          <a:p>
-            <a:pPr algn="ctr"/>
-          </a:p>
-        </p:txBody>
-      </p:sp>
-      <p:sp>
-        <p:nvSpPr>
-          <p:cNvPr id="11" name="TextBox 10"/>
-          <p:cNvSpPr txBox="1"/>
-          <p:nvPr/>
-        </p:nvSpPr>
-        <p:spPr>
-          <a:xfrm>
-            <a:off x="6537959" y="1847088"/>
-            <a:ext cx="640080" cy="457200"/>
-          </a:xfrm>
-          <a:prstGeom prst="rect">
-            <a:avLst/>
-          </a:prstGeom>
-          <a:noFill/>
-        </p:spPr>
-        <p:txBody>
-          <a:bodyPr wrap="square" anchor="t" lIns="0" rIns="0" tIns="0" bIns="0">
-            <a:spAutoFit/>
-          </a:bodyPr>
-          <a:lstStyle/>
-          <a:p>
-            <a:pPr algn="l">
-              <a:lnSpc>
-                <a:spcPct val="105000"/>
-              </a:lnSpc>
-            </a:pPr>
-            <a:r>
-              <a:rPr sz="1900" b="1">
-                <a:solidFill>
-                  <a:srgbClr val="25C6D2"/>
+                <a:spcPct val="130000"/>
+              </a:lnSpc>
+            </a:pPr>
+            <a:r>
+              <a:rPr sz="950" b="1">
+                <a:solidFill>
+                  <a:srgbClr val="9B8CFF"/>
                 </a:solidFill>
                 <a:latin typeface="Consolas"/>
               </a:rPr>
-              <a:t>02</a:t>
-            </a:r>
-          </a:p>
-        </p:txBody>
-      </p:sp>
-      <p:sp>
-        <p:nvSpPr>
-          <p:cNvPr id="12" name="TextBox 11"/>
-          <p:cNvSpPr txBox="1"/>
-          <p:nvPr/>
-        </p:nvSpPr>
-        <p:spPr>
-          <a:xfrm>
-            <a:off x="7223759" y="1865376"/>
-            <a:ext cx="4251960" cy="548640"/>
-          </a:xfrm>
-          <a:prstGeom prst="rect">
-            <a:avLst/>
-          </a:prstGeom>
-          <a:noFill/>
-        </p:spPr>
-        <p:txBody>
-          <a:bodyPr wrap="square" anchor="t" lIns="0" rIns="0" tIns="0" bIns="0">
-            <a:spAutoFit/>
-          </a:bodyPr>
-          <a:lstStyle/>
-          <a:p>
-            <a:pPr algn="l">
-              <a:lnSpc>
-                <a:spcPct val="100000"/>
-              </a:lnSpc>
-            </a:pPr>
-            <a:r>
-              <a:rPr sz="1400" b="1">
-                <a:solidFill>
-                  <a:srgbClr val="E7ECF2"/>
-                </a:solidFill>
-                <a:latin typeface="Arial"/>
-              </a:rPr>
-              <a:t>The variant ranking inverts by workload</a:t>
-            </a:r>
-          </a:p>
-        </p:txBody>
-      </p:sp>
-      <p:sp>
-        <p:nvSpPr>
-          <p:cNvPr id="13" name="TextBox 12"/>
-          <p:cNvSpPr txBox="1"/>
-          <p:nvPr/>
-        </p:nvSpPr>
-        <p:spPr>
-          <a:xfrm>
-            <a:off x="7223759" y="2395728"/>
-            <a:ext cx="4297680" cy="914400"/>
-          </a:xfrm>
-          <a:prstGeom prst="rect">
-            <a:avLst/>
-          </a:prstGeom>
-          <a:noFill/>
-        </p:spPr>
-        <p:txBody>
-          <a:bodyPr wrap="square" anchor="t" lIns="0" rIns="0" tIns="0" bIns="0">
-            <a:spAutoFit/>
-          </a:bodyPr>
-          <a:lstStyle/>
-          <a:p>
-            <a:pPr algn="l">
-              <a:lnSpc>
-                <a:spcPct val="118000"/>
-              </a:lnSpc>
-            </a:pPr>
-            <a:r>
-              <a:rPr sz="1130" b="0">
-                <a:solidFill>
-                  <a:srgbClr val="93A0AE"/>
-                </a:solidFill>
-                <a:latin typeface="Arial"/>
-              </a:rPr>
-              <a:t>At matched communication rate the order inverts: char-LM analog ≪ spiking-state ≪ output-spiking; precise recall (copy) the reverse — margin kept 0.87 / 0.50 / 0.074. A 1-bit state is at exactly chance, and cheapest.</a:t>
-            </a:r>
-          </a:p>
-        </p:txBody>
-      </p:sp>
-      <p:sp>
-        <p:nvSpPr>
-          <p:cNvPr id="14" name="Rounded Rectangle 13"/>
-          <p:cNvSpPr/>
-          <p:nvPr/>
-        </p:nvSpPr>
-        <p:spPr>
-          <a:xfrm>
-            <a:off x="548640" y="3520439"/>
-            <a:ext cx="5440680" cy="1691640"/>
-          </a:xfrm>
-          <a:prstGeom prst="roundRect">
-            <a:avLst>
-              <a:gd name="adj" fmla="val 8000"/>
-            </a:avLst>
-          </a:prstGeom>
-          <a:solidFill>
-            <a:srgbClr val="161C24"/>
-          </a:solidFill>
-          <a:ln w="12700">
-            <a:solidFill>
-              <a:srgbClr val="2A3440"/>
-            </a:solidFill>
-          </a:ln>
-          <a:effectLst/>
-        </p:spPr>
-        <p:style>
-          <a:lnRef idx="1">
-            <a:schemeClr val="accent1"/>
-          </a:lnRef>
-          <a:fillRef idx="3">
-            <a:schemeClr val="accent1"/>
-          </a:fillRef>
-          <a:effectRef idx="2">
-            <a:schemeClr val="accent1"/>
-          </a:effectRef>
-          <a:fontRef idx="minor">
-            <a:schemeClr val="lt1"/>
-          </a:fontRef>
-        </p:style>
-        <p:txBody>
-          <a:bodyPr rtlCol="0" anchor="ctr"/>
-          <a:lstStyle/>
-          <a:p>
-            <a:pPr algn="ctr"/>
-          </a:p>
-        </p:txBody>
-      </p:sp>
-      <p:sp>
-        <p:nvSpPr>
-          <p:cNvPr id="15" name="TextBox 14"/>
-          <p:cNvSpPr txBox="1"/>
-          <p:nvPr/>
-        </p:nvSpPr>
-        <p:spPr>
-          <a:xfrm>
-            <a:off x="822959" y="3721607"/>
-            <a:ext cx="640080" cy="457200"/>
-          </a:xfrm>
-          <a:prstGeom prst="rect">
-            <a:avLst/>
-          </a:prstGeom>
-          <a:noFill/>
-        </p:spPr>
-        <p:txBody>
-          <a:bodyPr wrap="square" anchor="t" lIns="0" rIns="0" tIns="0" bIns="0">
-            <a:spAutoFit/>
-          </a:bodyPr>
-          <a:lstStyle/>
-          <a:p>
-            <a:pPr algn="l">
-              <a:lnSpc>
-                <a:spcPct val="105000"/>
-              </a:lnSpc>
-            </a:pPr>
-            <a:r>
-              <a:rPr sz="1900" b="1">
-                <a:solidFill>
-                  <a:srgbClr val="25C6D2"/>
+              <a:t>SOURCES  </a:t>
+            </a:r>
+            <a:r>
+              <a:rPr sz="950" b="0">
+                <a:solidFill>
+                  <a:srgbClr val="667280"/>
                 </a:solidFill>
                 <a:latin typeface="Consolas"/>
               </a:rPr>
-              <a:t>03</a:t>
-            </a:r>
-          </a:p>
-        </p:txBody>
-      </p:sp>
-      <p:sp>
-        <p:nvSpPr>
-          <p:cNvPr id="16" name="TextBox 15"/>
-          <p:cNvSpPr txBox="1"/>
-          <p:nvPr/>
-        </p:nvSpPr>
-        <p:spPr>
-          <a:xfrm>
-            <a:off x="1508760" y="3739896"/>
-            <a:ext cx="4251960" cy="548640"/>
-          </a:xfrm>
-          <a:prstGeom prst="rect">
-            <a:avLst/>
-          </a:prstGeom>
-          <a:noFill/>
-        </p:spPr>
-        <p:txBody>
-          <a:bodyPr wrap="square" anchor="t" lIns="0" rIns="0" tIns="0" bIns="0">
-            <a:spAutoFit/>
-          </a:bodyPr>
-          <a:lstStyle/>
-          <a:p>
-            <a:pPr algn="l">
-              <a:lnSpc>
-                <a:spcPct val="100000"/>
-              </a:lnSpc>
-            </a:pPr>
-            <a:r>
-              <a:rPr sz="1400" b="1">
-                <a:solidFill>
-                  <a:srgbClr val="E7ECF2"/>
-                </a:solidFill>
-                <a:latin typeface="Arial"/>
-              </a:rPr>
-              <a:t>Degrade what the task ignores</a:t>
-            </a:r>
-          </a:p>
-        </p:txBody>
-      </p:sp>
-      <p:sp>
-        <p:nvSpPr>
-          <p:cNvPr id="17" name="TextBox 16"/>
-          <p:cNvSpPr txBox="1"/>
-          <p:nvPr/>
-        </p:nvSpPr>
-        <p:spPr>
-          <a:xfrm>
-            <a:off x="1508760" y="4270248"/>
-            <a:ext cx="4297680" cy="914400"/>
-          </a:xfrm>
-          <a:prstGeom prst="rect">
-            <a:avLst/>
-          </a:prstGeom>
-          <a:noFill/>
-        </p:spPr>
-        <p:txBody>
-          <a:bodyPr wrap="square" anchor="t" lIns="0" rIns="0" tIns="0" bIns="0">
-            <a:spAutoFit/>
-          </a:bodyPr>
-          <a:lstStyle/>
-          <a:p>
-            <a:pPr algn="l">
-              <a:lnSpc>
-                <a:spcPct val="118000"/>
-              </a:lnSpc>
-            </a:pPr>
-            <a:r>
-              <a:rPr sz="1130" b="0">
-                <a:solidFill>
-                  <a:srgbClr val="93A0AE"/>
-                </a:solidFill>
-                <a:latin typeface="Arial"/>
-              </a:rPr>
-              <a:t>One principle covers both: a degradation is cheap only where the loss does not depend on it. The same 6-bit state quantizer costs −0.002 bpc on char-LM and +0.37 on copy (post-hoc, not pre-registered).</a:t>
-            </a:r>
-          </a:p>
-        </p:txBody>
-      </p:sp>
-      <p:sp>
-        <p:nvSpPr>
-          <p:cNvPr id="18" name="Rounded Rectangle 17"/>
-          <p:cNvSpPr/>
-          <p:nvPr/>
-        </p:nvSpPr>
-        <p:spPr>
-          <a:xfrm>
-            <a:off x="6263640" y="3520439"/>
-            <a:ext cx="5440680" cy="1691640"/>
-          </a:xfrm>
-          <a:prstGeom prst="roundRect">
-            <a:avLst>
-              <a:gd name="adj" fmla="val 8000"/>
-            </a:avLst>
-          </a:prstGeom>
-          <a:solidFill>
-            <a:srgbClr val="161C24"/>
-          </a:solidFill>
-          <a:ln w="12700">
-            <a:solidFill>
-              <a:srgbClr val="2A3440"/>
-            </a:solidFill>
-          </a:ln>
-          <a:effectLst/>
-        </p:spPr>
-        <p:style>
-          <a:lnRef idx="1">
-            <a:schemeClr val="accent1"/>
-          </a:lnRef>
-          <a:fillRef idx="3">
-            <a:schemeClr val="accent1"/>
-          </a:fillRef>
-          <a:effectRef idx="2">
-            <a:schemeClr val="accent1"/>
-          </a:effectRef>
-          <a:fontRef idx="minor">
-            <a:schemeClr val="lt1"/>
-          </a:fontRef>
-        </p:style>
-        <p:txBody>
-          <a:bodyPr rtlCol="0" anchor="ctr"/>
-          <a:lstStyle/>
-          <a:p>
-            <a:pPr algn="ctr"/>
-          </a:p>
-        </p:txBody>
-      </p:sp>
-      <p:sp>
-        <p:nvSpPr>
-          <p:cNvPr id="19" name="TextBox 18"/>
-          <p:cNvSpPr txBox="1"/>
-          <p:nvPr/>
-        </p:nvSpPr>
-        <p:spPr>
-          <a:xfrm>
-            <a:off x="6537959" y="3721607"/>
-            <a:ext cx="640080" cy="457200"/>
-          </a:xfrm>
-          <a:prstGeom prst="rect">
-            <a:avLst/>
-          </a:prstGeom>
-          <a:noFill/>
-        </p:spPr>
-        <p:txBody>
-          <a:bodyPr wrap="square" anchor="t" lIns="0" rIns="0" tIns="0" bIns="0">
-            <a:spAutoFit/>
-          </a:bodyPr>
-          <a:lstStyle/>
-          <a:p>
-            <a:pPr algn="l">
-              <a:lnSpc>
-                <a:spcPct val="105000"/>
-              </a:lnSpc>
-            </a:pPr>
-            <a:r>
-              <a:rPr sz="1900" b="1">
-                <a:solidFill>
-                  <a:srgbClr val="25C6D2"/>
-                </a:solidFill>
-                <a:latin typeface="Consolas"/>
-              </a:rPr>
-              <a:t>04</a:t>
-            </a:r>
-          </a:p>
-        </p:txBody>
-      </p:sp>
-      <p:sp>
-        <p:nvSpPr>
-          <p:cNvPr id="20" name="TextBox 19"/>
-          <p:cNvSpPr txBox="1"/>
-          <p:nvPr/>
-        </p:nvSpPr>
-        <p:spPr>
-          <a:xfrm>
-            <a:off x="7223759" y="3739896"/>
-            <a:ext cx="4251960" cy="548640"/>
-          </a:xfrm>
-          <a:prstGeom prst="rect">
-            <a:avLst/>
-          </a:prstGeom>
-          <a:noFill/>
-        </p:spPr>
-        <p:txBody>
-          <a:bodyPr wrap="square" anchor="t" lIns="0" rIns="0" tIns="0" bIns="0">
-            <a:spAutoFit/>
-          </a:bodyPr>
-          <a:lstStyle/>
-          <a:p>
-            <a:pPr algn="l">
-              <a:lnSpc>
-                <a:spcPct val="100000"/>
-              </a:lnSpc>
-            </a:pPr>
-            <a:r>
-              <a:rPr sz="1400" b="1">
-                <a:solidFill>
-                  <a:srgbClr val="E7ECF2"/>
-                </a:solidFill>
-                <a:latin typeface="Arial"/>
-              </a:rPr>
-              <a:t>My own bound did not survive its test</a:t>
-            </a:r>
-          </a:p>
-        </p:txBody>
-      </p:sp>
-      <p:sp>
-        <p:nvSpPr>
-          <p:cNvPr id="21" name="TextBox 20"/>
-          <p:cNvSpPr txBox="1"/>
-          <p:nvPr/>
-        </p:nvSpPr>
-        <p:spPr>
-          <a:xfrm>
-            <a:off x="7223759" y="4270248"/>
-            <a:ext cx="4297680" cy="914400"/>
-          </a:xfrm>
-          <a:prstGeom prst="rect">
-            <a:avLst/>
-          </a:prstGeom>
-          <a:noFill/>
-        </p:spPr>
-        <p:txBody>
-          <a:bodyPr wrap="square" anchor="t" lIns="0" rIns="0" tIns="0" bIns="0">
-            <a:spAutoFit/>
-          </a:bodyPr>
-          <a:lstStyle/>
-          <a:p>
-            <a:pPr algn="l">
-              <a:lnSpc>
-                <a:spcPct val="118000"/>
-              </a:lnSpc>
-            </a:pPr>
-            <a:r>
-              <a:rPr sz="1130" b="0">
-                <a:solidFill>
-                  <a:srgbClr val="93A0AE"/>
-                </a:solidFill>
-                <a:latin typeface="Arial"/>
-              </a:rPr>
-              <a:t>Shrink-H, 3 seeds per width: the predicted floor rises 12× while measured state activity falls 0.496→0.250, and accuracy improves as capacity shrinks. Theory with a tested scope limit, not a validated prediction.</a:t>
+              <a:t>Predictive coding: Millidge+22, Salvatori/Song ICLR’24 (2506.06332) · EqProp: Scellier, EqSpike, 2606.03584 · SSM: Mamba, SpikingMamba 2510.04595, SpikySpace · JEPA: V-JEPA 2, LeJEPA · Hopfield: Ramsauer, 2411.08590 · Active inference: Friston, PMC12217590 · Sparsity Ceiling (this work, arXiv cs.NE)</a:t>
             </a:r>
           </a:p>
         </p:txBody>
@@ -11710,7 +11092,7 @@
                 </a:solidFill>
                 <a:latin typeface="Consolas"/>
               </a:rPr>
-              <a:t>08 · PROPOSED DIRECTIONS</a:t>
+              <a:t>07 · SSM RESULTS</a:t>
             </a:r>
           </a:p>
         </p:txBody>
@@ -11788,7 +11170,7 @@
                 </a:solidFill>
                 <a:latin typeface="Consolas"/>
               </a:rPr>
-              <a:t>09</a:t>
+              <a:t>08</a:t>
             </a:r>
           </a:p>
         </p:txBody>
@@ -11827,7 +11209,7 @@
                 </a:solidFill>
                 <a:latin typeface="Arial"/>
               </a:rPr>
-              <a:t>What I would work on next</a:t>
+              <a:t>Direction One, run: what the analog-state SSM actually did</a:t>
             </a:r>
           </a:p>
         </p:txBody>
@@ -11953,7 +11335,7 @@
                 </a:solidFill>
                 <a:latin typeface="Arial"/>
               </a:rPr>
-              <a:t>Analog state — done in simulation, open in silicon</a:t>
+              <a:t>Analog state buys energy, not quality</a:t>
             </a:r>
           </a:p>
         </p:txBody>
@@ -11992,7 +11374,7 @@
                 </a:solidFill>
                 <a:latin typeface="Arial"/>
               </a:rPr>
-              <a:t>Finished in simulation (two tasks, three seeds); what is unfinished is physical — every pJ figure is a 45nm proxy and the analog storage element and converter are unpriced. So 02 first, not more simulation.</a:t>
+              <a:t>Param-matched 4-way SSM, char-LM, 3 seeds: analog state cuts proxy energy 1.60× (446k vs 712k pJ/token) for +0.160 bpc. “Beats digital” is retracted — the same noise on the digital baseline is worth −0.309 bpc.</a:t>
             </a:r>
           </a:p>
         </p:txBody>
@@ -12118,7 +11500,7 @@
                 </a:solidFill>
                 <a:latin typeface="Arial"/>
               </a:rPr>
-              <a:t>Predictive coding on neuromorphic silicon</a:t>
+              <a:t>The variant ranking inverts by workload</a:t>
             </a:r>
           </a:p>
         </p:txBody>
@@ -12157,7 +11539,7 @@
                 </a:solidFill>
                 <a:latin typeface="Arial"/>
               </a:rPr>
-              <a:t>Implement an error-propagating hierarchy with local (EqProp) learning; measure real energy on Loihi 2 / SpiNNaker2 — turning the 45nm proxy into a measurement.</a:t>
+              <a:t>At matched communication rate the order inverts: char-LM analog ≪ spiking-state ≪ output-spiking; precise recall (copy) the reverse — margin kept 0.87 / 0.50 / 0.074. A 1-bit state is at exactly chance, and cheapest.</a:t>
             </a:r>
           </a:p>
         </p:txBody>
@@ -12283,7 +11665,7 @@
                 </a:solidFill>
                 <a:latin typeface="Arial"/>
               </a:rPr>
-              <a:t>Quantify the floor–vs–wall trade-off</a:t>
+              <a:t>Degrade what the task ignores</a:t>
             </a:r>
           </a:p>
         </p:txBody>
@@ -12322,7 +11704,7 @@
                 </a:solidFill>
                 <a:latin typeface="Arial"/>
               </a:rPr>
-              <a:t>Formalize the recurrence(firing floor) ↔ attention(memory wall) dichotomy as a conservation law; find the Pareto frontier and where analog-state models sit on it.</a:t>
+              <a:t>One principle covers both: a degradation is cheap only where the loss does not depend on it. The same 6-bit state quantizer costs −0.002 bpc on char-LM and +0.37 on copy (post-hoc, not pre-registered).</a:t>
             </a:r>
           </a:p>
         </p:txBody>
@@ -12448,7 +11830,7 @@
                 </a:solidFill>
                 <a:latin typeface="Arial"/>
               </a:rPr>
-              <a:t>Closed-loop world-model at the edge</a:t>
+              <a:t>My own bound did not survive its test</a:t>
             </a:r>
           </a:p>
         </p:txBody>
@@ -12487,7 +11869,172 @@
                 </a:solidFill>
                 <a:latin typeface="Arial"/>
               </a:rPr>
-              <a:t>A predictive world-model + planning loop for a low-power embodied agent — where neuromorphic's real-time, event-driven physics is decisive.</a:t>
+              <a:t>Shrink-H, 3 seeds per width: the predicted floor rises 12× while measured state activity falls 0.496→0.250, and accuracy improves as capacity shrinks. Theory with a tested scope limit, not a validated prediction.</a:t>
+            </a:r>
+          </a:p>
+        </p:txBody>
+      </p:sp>
+      <p:sp>
+        <p:nvSpPr>
+          <p:cNvPr id="48" name="energy-block-48"/>
+          <p:cNvSpPr/>
+          <p:nvPr/>
+        </p:nvSpPr>
+        <p:spPr>
+          <a:xfrm>
+            <a:off x="548640" y="5349240"/>
+            <a:ext cx="11155680" cy="914400"/>
+          </a:xfrm>
+          <a:prstGeom prst="roundRect">
+            <a:avLst>
+              <a:gd name="adj" fmla="val 8000"/>
+            </a:avLst>
+          </a:prstGeom>
+          <a:solidFill>
+            <a:srgbClr val="161C24"/>
+          </a:solidFill>
+          <a:ln w="12700">
+            <a:solidFill>
+              <a:srgbClr val="2A3440"/>
+            </a:solidFill>
+          </a:ln>
+          <a:effectLst/>
+        </p:spPr>
+        <p:style>
+          <a:lnRef idx="1">
+            <a:schemeClr val="accent1"/>
+          </a:lnRef>
+          <a:fillRef idx="3">
+            <a:schemeClr val="accent1"/>
+          </a:fillRef>
+          <a:effectRef idx="2">
+            <a:schemeClr val="accent1"/>
+          </a:effectRef>
+          <a:fontRef idx="minor">
+            <a:schemeClr val="lt1"/>
+          </a:fontRef>
+        </p:style>
+        <p:txBody>
+          <a:bodyPr rtlCol="0" anchor="ctr"/>
+          <a:lstStyle/>
+          <a:p>
+            <a:pPr algn="ctr"/>
+          </a:p>
+        </p:txBody>
+      </p:sp>
+      <p:sp>
+        <p:nvSpPr>
+          <p:cNvPr id="49" name="energy-block-49"/>
+          <p:cNvSpPr txBox="1"/>
+          <p:nvPr/>
+        </p:nvSpPr>
+        <p:spPr>
+          <a:xfrm>
+            <a:off x="822960" y="5513832"/>
+            <a:ext cx="640080" cy="457200"/>
+          </a:xfrm>
+          <a:prstGeom prst="rect">
+            <a:avLst/>
+          </a:prstGeom>
+          <a:noFill/>
+        </p:spPr>
+        <p:txBody>
+          <a:bodyPr wrap="square" anchor="t" lIns="0" rIns="0" tIns="0" bIns="0">
+            <a:spAutoFit/>
+          </a:bodyPr>
+          <a:lstStyle/>
+          <a:p>
+            <a:pPr algn="l">
+              <a:lnSpc>
+                <a:spcPct val="105000"/>
+              </a:lnSpc>
+            </a:pPr>
+            <a:r>
+              <a:rPr sz="1900" b="1">
+                <a:solidFill>
+                  <a:srgbClr val="25C6D2"/>
+                </a:solidFill>
+                <a:latin typeface="Consolas"/>
+              </a:rPr>
+              <a:t>05</a:t>
+            </a:r>
+          </a:p>
+        </p:txBody>
+      </p:sp>
+      <p:sp>
+        <p:nvSpPr>
+          <p:cNvPr id="50" name="energy-block-50"/>
+          <p:cNvSpPr txBox="1"/>
+          <p:nvPr/>
+        </p:nvSpPr>
+        <p:spPr>
+          <a:xfrm>
+            <a:off x="1508760" y="5477256"/>
+            <a:ext cx="3886200" cy="685800"/>
+          </a:xfrm>
+          <a:prstGeom prst="rect">
+            <a:avLst/>
+          </a:prstGeom>
+          <a:noFill/>
+        </p:spPr>
+        <p:txBody>
+          <a:bodyPr wrap="square" anchor="t" lIns="0" rIns="0" tIns="0" bIns="0">
+            <a:spAutoFit/>
+          </a:bodyPr>
+          <a:lstStyle/>
+          <a:p>
+            <a:pPr algn="l">
+              <a:lnSpc>
+                <a:spcPct val="100000"/>
+              </a:lnSpc>
+            </a:pPr>
+            <a:r>
+              <a:rPr sz="1400" b="1">
+                <a:solidFill>
+                  <a:srgbClr val="E7ECF2"/>
+                </a:solidFill>
+                <a:latin typeface="Arial"/>
+              </a:rPr>
+              <a:t>The energy is not where the mechanisms are</a:t>
+            </a:r>
+          </a:p>
+        </p:txBody>
+      </p:sp>
+      <p:sp>
+        <p:nvSpPr>
+          <p:cNvPr id="51" name="energy-block-51"/>
+          <p:cNvSpPr txBox="1"/>
+          <p:nvPr/>
+        </p:nvSpPr>
+        <p:spPr>
+          <a:xfrm>
+            <a:off x="5532120" y="5477256"/>
+            <a:ext cx="6035040" cy="713232"/>
+          </a:xfrm>
+          <a:prstGeom prst="rect">
+            <a:avLst/>
+          </a:prstGeom>
+          <a:noFill/>
+        </p:spPr>
+        <p:txBody>
+          <a:bodyPr wrap="square" anchor="t" lIns="0" rIns="0" tIns="0" bIns="0">
+            <a:spAutoFit/>
+          </a:bodyPr>
+          <a:lstStyle/>
+          <a:p>
+            <a:pPr algn="l">
+              <a:lnSpc>
+                <a:spcPct val="118000"/>
+              </a:lnSpc>
+            </a:pPr>
+            <a:r>
+              <a:rPr sz="1130" b="0">
+                <a:solidFill>
+                  <a:srgbClr val="93A0AE"/>
+                </a:solidFill>
+                <a:latin typeface="Arial"/>
+              </a:rPr>
+              <a:t>The readout carries 75% of analog's pJ/token, the recurrence 8%; even a free recurrence costs 1.74×. Gating the readout recovers the energy but costs ~+1.0 bpc (char-LM) and all of copy's margin, 3 seeds. Converters: 0.00–0.33%.</a:t>
             </a:r>
           </a:p>
         </p:txBody>
@@ -12520,23 +12067,183 @@
       <p:grpSpPr/>
       <p:sp>
         <p:nvSpPr>
-          <p:cNvPr id="2" name="Rectangle 1"/>
+          <p:cNvPr id="2" name="TextBox 1"/>
+          <p:cNvSpPr txBox="1"/>
+          <p:nvPr/>
+        </p:nvSpPr>
+        <p:spPr>
+          <a:xfrm>
+            <a:off x="548640" y="457200"/>
+            <a:ext cx="10972800" cy="274320"/>
+          </a:xfrm>
+          <a:prstGeom prst="rect">
+            <a:avLst/>
+          </a:prstGeom>
+          <a:noFill/>
+        </p:spPr>
+        <p:txBody>
+          <a:bodyPr wrap="square" anchor="t" lIns="0" rIns="0" tIns="0" bIns="0">
+            <a:spAutoFit/>
+          </a:bodyPr>
+          <a:lstStyle/>
+          <a:p>
+            <a:pPr algn="l">
+              <a:lnSpc>
+                <a:spcPct val="105000"/>
+              </a:lnSpc>
+            </a:pPr>
+            <a:r>
+              <a:rPr sz="1150" b="1" spc="140">
+                <a:solidFill>
+                  <a:srgbClr val="25C6D2"/>
+                </a:solidFill>
+                <a:latin typeface="Consolas"/>
+              </a:rPr>
+              <a:t>08 · PROPOSED DIRECTIONS</a:t>
+            </a:r>
+          </a:p>
+        </p:txBody>
+      </p:sp>
+      <p:sp>
+        <p:nvSpPr>
+          <p:cNvPr id="3" name="TextBox 2"/>
+          <p:cNvSpPr txBox="1"/>
+          <p:nvPr/>
+        </p:nvSpPr>
+        <p:spPr>
+          <a:xfrm>
+            <a:off x="548640" y="6400800"/>
+            <a:ext cx="8229600" cy="274320"/>
+          </a:xfrm>
+          <a:prstGeom prst="rect">
+            <a:avLst/>
+          </a:prstGeom>
+          <a:noFill/>
+        </p:spPr>
+        <p:txBody>
+          <a:bodyPr wrap="square" anchor="t" lIns="0" rIns="0" tIns="0" bIns="0">
+            <a:spAutoFit/>
+          </a:bodyPr>
+          <a:lstStyle/>
+          <a:p>
+            <a:pPr algn="l">
+              <a:lnSpc>
+                <a:spcPct val="105000"/>
+              </a:lnSpc>
+            </a:pPr>
+            <a:r>
+              <a:rPr sz="850" b="0" spc="110">
+                <a:solidFill>
+                  <a:srgbClr val="667280"/>
+                </a:solidFill>
+                <a:latin typeface="Consolas"/>
+              </a:rPr>
+              <a:t>BEYOND ATTENTION · NEUROMORPHIC INTELLIGENCE PARADIGMS</a:t>
+            </a:r>
+          </a:p>
+        </p:txBody>
+      </p:sp>
+      <p:sp>
+        <p:nvSpPr>
+          <p:cNvPr id="4" name="TextBox 3"/>
+          <p:cNvSpPr txBox="1"/>
+          <p:nvPr/>
+        </p:nvSpPr>
+        <p:spPr>
+          <a:xfrm>
+            <a:off x="10911535" y="6400800"/>
+            <a:ext cx="731520" cy="274320"/>
+          </a:xfrm>
+          <a:prstGeom prst="rect">
+            <a:avLst/>
+          </a:prstGeom>
+          <a:noFill/>
+        </p:spPr>
+        <p:txBody>
+          <a:bodyPr wrap="square" anchor="t" lIns="0" rIns="0" tIns="0" bIns="0">
+            <a:spAutoFit/>
+          </a:bodyPr>
+          <a:lstStyle/>
+          <a:p>
+            <a:pPr algn="r">
+              <a:lnSpc>
+                <a:spcPct val="105000"/>
+              </a:lnSpc>
+            </a:pPr>
+            <a:r>
+              <a:rPr sz="850" b="0">
+                <a:solidFill>
+                  <a:srgbClr val="667280"/>
+                </a:solidFill>
+                <a:latin typeface="Consolas"/>
+              </a:rPr>
+              <a:t>09</a:t>
+            </a:r>
+          </a:p>
+        </p:txBody>
+      </p:sp>
+      <p:sp>
+        <p:nvSpPr>
+          <p:cNvPr id="5" name="TextBox 4"/>
+          <p:cNvSpPr txBox="1"/>
+          <p:nvPr/>
+        </p:nvSpPr>
+        <p:spPr>
+          <a:xfrm>
+            <a:off x="548640" y="822960"/>
+            <a:ext cx="10972800" cy="548640"/>
+          </a:xfrm>
+          <a:prstGeom prst="rect">
+            <a:avLst/>
+          </a:prstGeom>
+          <a:noFill/>
+        </p:spPr>
+        <p:txBody>
+          <a:bodyPr wrap="square" anchor="t" lIns="0" rIns="0" tIns="0" bIns="0">
+            <a:spAutoFit/>
+          </a:bodyPr>
+          <a:lstStyle/>
+          <a:p>
+            <a:pPr algn="l">
+              <a:lnSpc>
+                <a:spcPct val="105000"/>
+              </a:lnSpc>
+            </a:pPr>
+            <a:r>
+              <a:rPr sz="2400" b="1">
+                <a:solidFill>
+                  <a:srgbClr val="E7ECF2"/>
+                </a:solidFill>
+                <a:latin typeface="Arial"/>
+              </a:rPr>
+              <a:t>What I would work on next</a:t>
+            </a:r>
+          </a:p>
+        </p:txBody>
+      </p:sp>
+      <p:sp>
+        <p:nvSpPr>
+          <p:cNvPr id="6" name="Rounded Rectangle 5"/>
           <p:cNvSpPr/>
           <p:nvPr/>
         </p:nvSpPr>
         <p:spPr>
           <a:xfrm>
-            <a:off x="0" y="0"/>
-            <a:ext cx="146304" cy="6858000"/>
-          </a:xfrm>
-          <a:prstGeom prst="rect">
-            <a:avLst/>
+            <a:off x="548640" y="1645920"/>
+            <a:ext cx="5440680" cy="1691640"/>
+          </a:xfrm>
+          <a:prstGeom prst="roundRect">
+            <a:avLst>
+              <a:gd name="adj" fmla="val 8000"/>
+            </a:avLst>
           </a:prstGeom>
           <a:solidFill>
-            <a:srgbClr val="9B8CFF"/>
+            <a:srgbClr val="161C24"/>
           </a:solidFill>
-          <a:ln>
-            <a:noFill/>
+          <a:ln w="12700">
+            <a:solidFill>
+              <a:srgbClr val="2A3440"/>
+            </a:solidFill>
           </a:ln>
           <a:effectLst/>
         </p:spPr>
@@ -12564,14 +12271,14 @@
       </p:sp>
       <p:sp>
         <p:nvSpPr>
-          <p:cNvPr id="3" name="TextBox 2"/>
-          <p:cNvSpPr txBox="1"/>
-          <p:nvPr/>
-        </p:nvSpPr>
-        <p:spPr>
-          <a:xfrm>
-            <a:off x="822960" y="1371600"/>
-            <a:ext cx="10972800" cy="274320"/>
+          <p:cNvPr id="7" name="TextBox 6"/>
+          <p:cNvSpPr txBox="1"/>
+          <p:nvPr/>
+        </p:nvSpPr>
+        <p:spPr>
+          <a:xfrm>
+            <a:off x="822959" y="1847088"/>
+            <a:ext cx="640080" cy="457200"/>
           </a:xfrm>
           <a:prstGeom prst="rect">
             <a:avLst/>
@@ -12590,27 +12297,27 @@
               </a:lnSpc>
             </a:pPr>
             <a:r>
-              <a:rPr sz="1150" b="1" spc="140">
-                <a:solidFill>
-                  <a:srgbClr val="9B8CFF"/>
+              <a:rPr sz="1900" b="1">
+                <a:solidFill>
+                  <a:srgbClr val="25C6D2"/>
                 </a:solidFill>
                 <a:latin typeface="Consolas"/>
               </a:rPr>
-              <a:t>THESIS</a:t>
-            </a:r>
-          </a:p>
-        </p:txBody>
-      </p:sp>
-      <p:sp>
-        <p:nvSpPr>
-          <p:cNvPr id="4" name="TextBox 3"/>
-          <p:cNvSpPr txBox="1"/>
-          <p:nvPr/>
-        </p:nvSpPr>
-        <p:spPr>
-          <a:xfrm>
-            <a:off x="786384" y="1828800"/>
-            <a:ext cx="10424160" cy="2377440"/>
+              <a:t>01</a:t>
+            </a:r>
+          </a:p>
+        </p:txBody>
+      </p:sp>
+      <p:sp>
+        <p:nvSpPr>
+          <p:cNvPr id="8" name="TextBox 7"/>
+          <p:cNvSpPr txBox="1"/>
+          <p:nvPr/>
+        </p:nvSpPr>
+        <p:spPr>
+          <a:xfrm>
+            <a:off x="1508760" y="1865376"/>
+            <a:ext cx="4251960" cy="548640"/>
           </a:xfrm>
           <a:prstGeom prst="rect">
             <a:avLst/>
@@ -12625,59 +12332,283 @@
           <a:p>
             <a:pPr algn="l">
               <a:lnSpc>
-                <a:spcPct val="110000"/>
-              </a:lnSpc>
-            </a:pPr>
-            <a:r>
-              <a:rPr sz="3000" b="1">
+                <a:spcPct val="100000"/>
+              </a:lnSpc>
+            </a:pPr>
+            <a:r>
+              <a:rPr sz="1400" b="1">
                 <a:solidFill>
                   <a:srgbClr val="E7ECF2"/>
                 </a:solidFill>
                 <a:latin typeface="Arial"/>
               </a:rPr>
-              <a:t>Intelligence is a loop, not a lookup.
-</a:t>
-            </a:r>
-            <a:r>
-              <a:rPr sz="2000" b="1">
+              <a:t>Analog state — done in simulation, open in silicon</a:t>
+            </a:r>
+          </a:p>
+        </p:txBody>
+      </p:sp>
+      <p:sp>
+        <p:nvSpPr>
+          <p:cNvPr id="9" name="TextBox 8"/>
+          <p:cNvSpPr txBox="1"/>
+          <p:nvPr/>
+        </p:nvSpPr>
+        <p:spPr>
+          <a:xfrm>
+            <a:off x="1508760" y="2395728"/>
+            <a:ext cx="4297680" cy="914400"/>
+          </a:xfrm>
+          <a:prstGeom prst="rect">
+            <a:avLst/>
+          </a:prstGeom>
+          <a:noFill/>
+        </p:spPr>
+        <p:txBody>
+          <a:bodyPr wrap="square" anchor="t" lIns="0" rIns="0" tIns="0" bIns="0">
+            <a:spAutoFit/>
+          </a:bodyPr>
+          <a:lstStyle/>
+          <a:p>
+            <a:pPr algn="l">
+              <a:lnSpc>
+                <a:spcPct val="118000"/>
+              </a:lnSpc>
+            </a:pPr>
+            <a:r>
+              <a:rPr sz="1130" b="0">
                 <a:solidFill>
                   <a:srgbClr val="93A0AE"/>
                 </a:solidFill>
                 <a:latin typeface="Arial"/>
               </a:rPr>
-              <a:t>If neuromorphic can't ride attention, it shouldn't — its physics aligns with the </a:t>
-            </a:r>
-            <a:r>
-              <a:rPr sz="2000" b="1">
-                <a:solidFill>
-                  <a:srgbClr val="9B8CFF"/>
+              <a:t>Finished in simulation, including the energy datapath: the readout's 75% share resisted every gating mechanism tested. What is unfinished is physical — every pJ figure is a 45nm proxy. So 02 first, not more simulation.</a:t>
+            </a:r>
+          </a:p>
+        </p:txBody>
+      </p:sp>
+      <p:sp>
+        <p:nvSpPr>
+          <p:cNvPr id="10" name="Rounded Rectangle 9"/>
+          <p:cNvSpPr/>
+          <p:nvPr/>
+        </p:nvSpPr>
+        <p:spPr>
+          <a:xfrm>
+            <a:off x="6263640" y="1645920"/>
+            <a:ext cx="5440680" cy="1691640"/>
+          </a:xfrm>
+          <a:prstGeom prst="roundRect">
+            <a:avLst>
+              <a:gd name="adj" fmla="val 8000"/>
+            </a:avLst>
+          </a:prstGeom>
+          <a:solidFill>
+            <a:srgbClr val="161C24"/>
+          </a:solidFill>
+          <a:ln w="12700">
+            <a:solidFill>
+              <a:srgbClr val="2A3440"/>
+            </a:solidFill>
+          </a:ln>
+          <a:effectLst/>
+        </p:spPr>
+        <p:style>
+          <a:lnRef idx="1">
+            <a:schemeClr val="accent1"/>
+          </a:lnRef>
+          <a:fillRef idx="3">
+            <a:schemeClr val="accent1"/>
+          </a:fillRef>
+          <a:effectRef idx="2">
+            <a:schemeClr val="accent1"/>
+          </a:effectRef>
+          <a:fontRef idx="minor">
+            <a:schemeClr val="lt1"/>
+          </a:fontRef>
+        </p:style>
+        <p:txBody>
+          <a:bodyPr rtlCol="0" anchor="ctr"/>
+          <a:lstStyle/>
+          <a:p>
+            <a:pPr algn="ctr"/>
+          </a:p>
+        </p:txBody>
+      </p:sp>
+      <p:sp>
+        <p:nvSpPr>
+          <p:cNvPr id="11" name="TextBox 10"/>
+          <p:cNvSpPr txBox="1"/>
+          <p:nvPr/>
+        </p:nvSpPr>
+        <p:spPr>
+          <a:xfrm>
+            <a:off x="6537959" y="1847088"/>
+            <a:ext cx="640080" cy="457200"/>
+          </a:xfrm>
+          <a:prstGeom prst="rect">
+            <a:avLst/>
+          </a:prstGeom>
+          <a:noFill/>
+        </p:spPr>
+        <p:txBody>
+          <a:bodyPr wrap="square" anchor="t" lIns="0" rIns="0" tIns="0" bIns="0">
+            <a:spAutoFit/>
+          </a:bodyPr>
+          <a:lstStyle/>
+          <a:p>
+            <a:pPr algn="l">
+              <a:lnSpc>
+                <a:spcPct val="105000"/>
+              </a:lnSpc>
+            </a:pPr>
+            <a:r>
+              <a:rPr sz="1900" b="1">
+                <a:solidFill>
+                  <a:srgbClr val="25C6D2"/>
+                </a:solidFill>
+                <a:latin typeface="Consolas"/>
+              </a:rPr>
+              <a:t>02</a:t>
+            </a:r>
+          </a:p>
+        </p:txBody>
+      </p:sp>
+      <p:sp>
+        <p:nvSpPr>
+          <p:cNvPr id="12" name="TextBox 11"/>
+          <p:cNvSpPr txBox="1"/>
+          <p:nvPr/>
+        </p:nvSpPr>
+        <p:spPr>
+          <a:xfrm>
+            <a:off x="7223759" y="1865376"/>
+            <a:ext cx="4251960" cy="548640"/>
+          </a:xfrm>
+          <a:prstGeom prst="rect">
+            <a:avLst/>
+          </a:prstGeom>
+          <a:noFill/>
+        </p:spPr>
+        <p:txBody>
+          <a:bodyPr wrap="square" anchor="t" lIns="0" rIns="0" tIns="0" bIns="0">
+            <a:spAutoFit/>
+          </a:bodyPr>
+          <a:lstStyle/>
+          <a:p>
+            <a:pPr algn="l">
+              <a:lnSpc>
+                <a:spcPct val="100000"/>
+              </a:lnSpc>
+            </a:pPr>
+            <a:r>
+              <a:rPr sz="1400" b="1">
+                <a:solidFill>
+                  <a:srgbClr val="E7ECF2"/>
                 </a:solidFill>
                 <a:latin typeface="Arial"/>
               </a:rPr>
-              <a:t>predictive, sparse, local, embodied</a:t>
-            </a:r>
-            <a:r>
-              <a:rPr sz="2000" b="1">
+              <a:t>Predictive coding on neuromorphic silicon</a:t>
+            </a:r>
+          </a:p>
+        </p:txBody>
+      </p:sp>
+      <p:sp>
+        <p:nvSpPr>
+          <p:cNvPr id="13" name="TextBox 12"/>
+          <p:cNvSpPr txBox="1"/>
+          <p:nvPr/>
+        </p:nvSpPr>
+        <p:spPr>
+          <a:xfrm>
+            <a:off x="7223759" y="2395728"/>
+            <a:ext cx="4297680" cy="914400"/>
+          </a:xfrm>
+          <a:prstGeom prst="rect">
+            <a:avLst/>
+          </a:prstGeom>
+          <a:noFill/>
+        </p:spPr>
+        <p:txBody>
+          <a:bodyPr wrap="square" anchor="t" lIns="0" rIns="0" tIns="0" bIns="0">
+            <a:spAutoFit/>
+          </a:bodyPr>
+          <a:lstStyle/>
+          <a:p>
+            <a:pPr algn="l">
+              <a:lnSpc>
+                <a:spcPct val="118000"/>
+              </a:lnSpc>
+            </a:pPr>
+            <a:r>
+              <a:rPr sz="1130" b="0">
                 <a:solidFill>
                   <a:srgbClr val="93A0AE"/>
                 </a:solidFill>
                 <a:latin typeface="Arial"/>
               </a:rPr>
-              <a:t> paradigm the brain already proves works at 20 W.</a:t>
-            </a:r>
-          </a:p>
-        </p:txBody>
-      </p:sp>
-      <p:sp>
-        <p:nvSpPr>
-          <p:cNvPr id="5" name="TextBox 4"/>
-          <p:cNvSpPr txBox="1"/>
-          <p:nvPr/>
-        </p:nvSpPr>
-        <p:spPr>
-          <a:xfrm>
-            <a:off x="822960" y="4937760"/>
-            <a:ext cx="10515600" cy="1097280"/>
+              <a:t>Implement an error-propagating hierarchy with local (EqProp) learning; measure real energy on Loihi 2 / SpiNNaker2 — turning the 45nm proxy into a measurement.</a:t>
+            </a:r>
+          </a:p>
+        </p:txBody>
+      </p:sp>
+      <p:sp>
+        <p:nvSpPr>
+          <p:cNvPr id="14" name="Rounded Rectangle 13"/>
+          <p:cNvSpPr/>
+          <p:nvPr/>
+        </p:nvSpPr>
+        <p:spPr>
+          <a:xfrm>
+            <a:off x="548640" y="3520439"/>
+            <a:ext cx="5440680" cy="1691640"/>
+          </a:xfrm>
+          <a:prstGeom prst="roundRect">
+            <a:avLst>
+              <a:gd name="adj" fmla="val 8000"/>
+            </a:avLst>
+          </a:prstGeom>
+          <a:solidFill>
+            <a:srgbClr val="161C24"/>
+          </a:solidFill>
+          <a:ln w="12700">
+            <a:solidFill>
+              <a:srgbClr val="2A3440"/>
+            </a:solidFill>
+          </a:ln>
+          <a:effectLst/>
+        </p:spPr>
+        <p:style>
+          <a:lnRef idx="1">
+            <a:schemeClr val="accent1"/>
+          </a:lnRef>
+          <a:fillRef idx="3">
+            <a:schemeClr val="accent1"/>
+          </a:fillRef>
+          <a:effectRef idx="2">
+            <a:schemeClr val="accent1"/>
+          </a:effectRef>
+          <a:fontRef idx="minor">
+            <a:schemeClr val="lt1"/>
+          </a:fontRef>
+        </p:style>
+        <p:txBody>
+          <a:bodyPr rtlCol="0" anchor="ctr"/>
+          <a:lstStyle/>
+          <a:p>
+            <a:pPr algn="ctr"/>
+          </a:p>
+        </p:txBody>
+      </p:sp>
+      <p:sp>
+        <p:nvSpPr>
+          <p:cNvPr id="15" name="TextBox 14"/>
+          <p:cNvSpPr txBox="1"/>
+          <p:nvPr/>
+        </p:nvSpPr>
+        <p:spPr>
+          <a:xfrm>
+            <a:off x="822959" y="3721607"/>
+            <a:ext cx="640080" cy="457200"/>
           </a:xfrm>
           <a:prstGeom prst="rect">
             <a:avLst/>
@@ -12692,26 +12623,260 @@
           <a:p>
             <a:pPr algn="l">
               <a:lnSpc>
-                <a:spcPct val="130000"/>
-              </a:lnSpc>
-            </a:pPr>
-            <a:r>
-              <a:rPr sz="950" b="1">
-                <a:solidFill>
-                  <a:srgbClr val="9B8CFF"/>
+                <a:spcPct val="105000"/>
+              </a:lnSpc>
+            </a:pPr>
+            <a:r>
+              <a:rPr sz="1900" b="1">
+                <a:solidFill>
+                  <a:srgbClr val="25C6D2"/>
                 </a:solidFill>
                 <a:latin typeface="Consolas"/>
               </a:rPr>
-              <a:t>SOURCES  </a:t>
-            </a:r>
-            <a:r>
-              <a:rPr sz="950" b="0">
-                <a:solidFill>
-                  <a:srgbClr val="667280"/>
+              <a:t>03</a:t>
+            </a:r>
+          </a:p>
+        </p:txBody>
+      </p:sp>
+      <p:sp>
+        <p:nvSpPr>
+          <p:cNvPr id="16" name="TextBox 15"/>
+          <p:cNvSpPr txBox="1"/>
+          <p:nvPr/>
+        </p:nvSpPr>
+        <p:spPr>
+          <a:xfrm>
+            <a:off x="1508760" y="3739896"/>
+            <a:ext cx="4251960" cy="548640"/>
+          </a:xfrm>
+          <a:prstGeom prst="rect">
+            <a:avLst/>
+          </a:prstGeom>
+          <a:noFill/>
+        </p:spPr>
+        <p:txBody>
+          <a:bodyPr wrap="square" anchor="t" lIns="0" rIns="0" tIns="0" bIns="0">
+            <a:spAutoFit/>
+          </a:bodyPr>
+          <a:lstStyle/>
+          <a:p>
+            <a:pPr algn="l">
+              <a:lnSpc>
+                <a:spcPct val="100000"/>
+              </a:lnSpc>
+            </a:pPr>
+            <a:r>
+              <a:rPr sz="1400" b="1">
+                <a:solidFill>
+                  <a:srgbClr val="E7ECF2"/>
+                </a:solidFill>
+                <a:latin typeface="Arial"/>
+              </a:rPr>
+              <a:t>Quantify the floor–vs–wall trade-off</a:t>
+            </a:r>
+          </a:p>
+        </p:txBody>
+      </p:sp>
+      <p:sp>
+        <p:nvSpPr>
+          <p:cNvPr id="17" name="TextBox 16"/>
+          <p:cNvSpPr txBox="1"/>
+          <p:nvPr/>
+        </p:nvSpPr>
+        <p:spPr>
+          <a:xfrm>
+            <a:off x="1508760" y="4270248"/>
+            <a:ext cx="4297680" cy="914400"/>
+          </a:xfrm>
+          <a:prstGeom prst="rect">
+            <a:avLst/>
+          </a:prstGeom>
+          <a:noFill/>
+        </p:spPr>
+        <p:txBody>
+          <a:bodyPr wrap="square" anchor="t" lIns="0" rIns="0" tIns="0" bIns="0">
+            <a:spAutoFit/>
+          </a:bodyPr>
+          <a:lstStyle/>
+          <a:p>
+            <a:pPr algn="l">
+              <a:lnSpc>
+                <a:spcPct val="118000"/>
+              </a:lnSpc>
+            </a:pPr>
+            <a:r>
+              <a:rPr sz="1130" b="0">
+                <a:solidFill>
+                  <a:srgbClr val="93A0AE"/>
+                </a:solidFill>
+                <a:latin typeface="Arial"/>
+              </a:rPr>
+              <a:t>Formalize the recurrence(firing floor) ↔ attention(memory wall) dichotomy as a conservation law; find the Pareto frontier and where analog-state models sit on it.</a:t>
+            </a:r>
+          </a:p>
+        </p:txBody>
+      </p:sp>
+      <p:sp>
+        <p:nvSpPr>
+          <p:cNvPr id="18" name="Rounded Rectangle 17"/>
+          <p:cNvSpPr/>
+          <p:nvPr/>
+        </p:nvSpPr>
+        <p:spPr>
+          <a:xfrm>
+            <a:off x="6263640" y="3520439"/>
+            <a:ext cx="5440680" cy="1691640"/>
+          </a:xfrm>
+          <a:prstGeom prst="roundRect">
+            <a:avLst>
+              <a:gd name="adj" fmla="val 8000"/>
+            </a:avLst>
+          </a:prstGeom>
+          <a:solidFill>
+            <a:srgbClr val="161C24"/>
+          </a:solidFill>
+          <a:ln w="12700">
+            <a:solidFill>
+              <a:srgbClr val="2A3440"/>
+            </a:solidFill>
+          </a:ln>
+          <a:effectLst/>
+        </p:spPr>
+        <p:style>
+          <a:lnRef idx="1">
+            <a:schemeClr val="accent1"/>
+          </a:lnRef>
+          <a:fillRef idx="3">
+            <a:schemeClr val="accent1"/>
+          </a:fillRef>
+          <a:effectRef idx="2">
+            <a:schemeClr val="accent1"/>
+          </a:effectRef>
+          <a:fontRef idx="minor">
+            <a:schemeClr val="lt1"/>
+          </a:fontRef>
+        </p:style>
+        <p:txBody>
+          <a:bodyPr rtlCol="0" anchor="ctr"/>
+          <a:lstStyle/>
+          <a:p>
+            <a:pPr algn="ctr"/>
+          </a:p>
+        </p:txBody>
+      </p:sp>
+      <p:sp>
+        <p:nvSpPr>
+          <p:cNvPr id="19" name="TextBox 18"/>
+          <p:cNvSpPr txBox="1"/>
+          <p:nvPr/>
+        </p:nvSpPr>
+        <p:spPr>
+          <a:xfrm>
+            <a:off x="6537959" y="3721607"/>
+            <a:ext cx="640080" cy="457200"/>
+          </a:xfrm>
+          <a:prstGeom prst="rect">
+            <a:avLst/>
+          </a:prstGeom>
+          <a:noFill/>
+        </p:spPr>
+        <p:txBody>
+          <a:bodyPr wrap="square" anchor="t" lIns="0" rIns="0" tIns="0" bIns="0">
+            <a:spAutoFit/>
+          </a:bodyPr>
+          <a:lstStyle/>
+          <a:p>
+            <a:pPr algn="l">
+              <a:lnSpc>
+                <a:spcPct val="105000"/>
+              </a:lnSpc>
+            </a:pPr>
+            <a:r>
+              <a:rPr sz="1900" b="1">
+                <a:solidFill>
+                  <a:srgbClr val="25C6D2"/>
                 </a:solidFill>
                 <a:latin typeface="Consolas"/>
               </a:rPr>
-              <a:t>Predictive coding: Millidge+22, Salvatori/Song ICLR’24 (2506.06332) · EqProp: Scellier, EqSpike, 2606.03584 · SSM: Mamba, SpikingMamba 2510.04595, SpikySpace · JEPA: V-JEPA 2, LeJEPA · Hopfield: Ramsauer, 2411.08590 · Active inference: Friston, PMC12217590 · Sparsity Ceiling (this work, arXiv cs.NE)</a:t>
+              <a:t>04</a:t>
+            </a:r>
+          </a:p>
+        </p:txBody>
+      </p:sp>
+      <p:sp>
+        <p:nvSpPr>
+          <p:cNvPr id="20" name="TextBox 19"/>
+          <p:cNvSpPr txBox="1"/>
+          <p:nvPr/>
+        </p:nvSpPr>
+        <p:spPr>
+          <a:xfrm>
+            <a:off x="7223759" y="3739896"/>
+            <a:ext cx="4251960" cy="548640"/>
+          </a:xfrm>
+          <a:prstGeom prst="rect">
+            <a:avLst/>
+          </a:prstGeom>
+          <a:noFill/>
+        </p:spPr>
+        <p:txBody>
+          <a:bodyPr wrap="square" anchor="t" lIns="0" rIns="0" tIns="0" bIns="0">
+            <a:spAutoFit/>
+          </a:bodyPr>
+          <a:lstStyle/>
+          <a:p>
+            <a:pPr algn="l">
+              <a:lnSpc>
+                <a:spcPct val="100000"/>
+              </a:lnSpc>
+            </a:pPr>
+            <a:r>
+              <a:rPr sz="1400" b="1">
+                <a:solidFill>
+                  <a:srgbClr val="E7ECF2"/>
+                </a:solidFill>
+                <a:latin typeface="Arial"/>
+              </a:rPr>
+              <a:t>Closed-loop world-model at the edge</a:t>
+            </a:r>
+          </a:p>
+        </p:txBody>
+      </p:sp>
+      <p:sp>
+        <p:nvSpPr>
+          <p:cNvPr id="21" name="TextBox 20"/>
+          <p:cNvSpPr txBox="1"/>
+          <p:nvPr/>
+        </p:nvSpPr>
+        <p:spPr>
+          <a:xfrm>
+            <a:off x="7223759" y="4270248"/>
+            <a:ext cx="4297680" cy="914400"/>
+          </a:xfrm>
+          <a:prstGeom prst="rect">
+            <a:avLst/>
+          </a:prstGeom>
+          <a:noFill/>
+        </p:spPr>
+        <p:txBody>
+          <a:bodyPr wrap="square" anchor="t" lIns="0" rIns="0" tIns="0" bIns="0">
+            <a:spAutoFit/>
+          </a:bodyPr>
+          <a:lstStyle/>
+          <a:p>
+            <a:pPr algn="l">
+              <a:lnSpc>
+                <a:spcPct val="118000"/>
+              </a:lnSpc>
+            </a:pPr>
+            <a:r>
+              <a:rPr sz="1130" b="0">
+                <a:solidFill>
+                  <a:srgbClr val="93A0AE"/>
+                </a:solidFill>
+                <a:latin typeface="Arial"/>
+              </a:rPr>
+              <a:t>A predictive world-model + planning loop for a low-power embodied agent — where neuromorphic's real-time, event-driven physics is decisive.</a:t>
             </a:r>
           </a:p>
         </p:txBody>

</xml_diff>

<commit_message>
deck: shape-law/streaming narrowing — band-05 verdict now unqualified (no quality-matched pJ win at any shape/budget tested)
Co-Authored-By: Claude Fable 5 <noreply@anthropic.com>
</commit_message>
<xml_diff>
--- a/talk/beyond_attention_paradigms.pptx
+++ b/talk/beyond_attention_paradigms.pptx
@@ -11995,7 +11995,7 @@
                 </a:solidFill>
                 <a:latin typeface="Arial"/>
               </a:rPr>
-              <a:t>The energy is not where the mechanisms are</a:t>
+              <a:t>No quality-matched pJ win at any shape tested</a:t>
             </a:r>
           </a:p>
         </p:txBody>
@@ -12034,7 +12034,7 @@
                 </a:solidFill>
                 <a:latin typeface="Arial"/>
               </a:rPr>
-              <a:t>The readout carries 75% of analog's pJ/token, the recurrence 8%; even a free recurrence costs 1.74×. Gating the readout recovers the energy but costs ~+1.0 bpc (char-LM) and all of copy's margin, 3 seeds. Converters: 0.00–0.33%.</a:t>
+              <a:t>LM shape: readout = 75% of analog’s pJ/token, recurrence 8%; gating it costs ~+1.0 bpc and all of copy’s margin (3 seeds). Streaming shape (V/H=0.04): recurrence dominates, 3.3× recoverable — but −10…−19 pts, budget-robust. Converters ≤0.58%.</a:t>
             </a:r>
           </a:p>
         </p:txBody>
@@ -12381,7 +12381,7 @@
                 </a:solidFill>
                 <a:latin typeface="Arial"/>
               </a:rPr>
-              <a:t>Finished in simulation, including the energy datapath: the readout's 75% share resisted every gating mechanism tested. What is unfinished is physical — every pJ figure is a 45nm proxy. So 02 first, not more simulation.</a:t>
+              <a:t>Done in simulation at both shapes: LM — the readout’s 75% share resisted every gating mechanism; streaming — 3.3× is recoverable but costs 10–19 pts, budget-robust. What’s unfinished is physical: every pJ is a 45nm proxy. So 02 first, not more simulation.</a:t>
             </a:r>
           </a:p>
         </p:txBody>

</xml_diff>